<commit_message>
Update Chapter 10 lesson and slides
</commit_message>
<xml_diff>
--- a/slides/chapter_10_How_to_Work_with_Strings.pptx
+++ b/slides/chapter_10_How_to_Work_with_Strings.pptx
@@ -7,20 +7,22 @@
   <p:sldIdLst>
     <p:sldId id="256" r:id="rId2"/>
     <p:sldId id="257" r:id="rId3"/>
-    <p:sldId id="258" r:id="rId4"/>
-    <p:sldId id="259" r:id="rId5"/>
-    <p:sldId id="260" r:id="rId6"/>
-    <p:sldId id="261" r:id="rId7"/>
-    <p:sldId id="262" r:id="rId8"/>
-    <p:sldId id="263" r:id="rId9"/>
+    <p:sldId id="264" r:id="rId4"/>
+    <p:sldId id="258" r:id="rId5"/>
+    <p:sldId id="259" r:id="rId6"/>
+    <p:sldId id="260" r:id="rId7"/>
+    <p:sldId id="261" r:id="rId8"/>
+    <p:sldId id="262" r:id="rId9"/>
+    <p:sldId id="265" r:id="rId10"/>
+    <p:sldId id="263" r:id="rId11"/>
   </p:sldIdLst>
   <p:sldSz cx="18288000" cy="10287000"/>
   <p:notesSz cx="6858000" cy="9144000"/>
   <p:embeddedFontLst>
     <p:embeddedFont>
       <p:font typeface="Times New Roman Bold" panose="02020803070505020304" pitchFamily="18" charset="0"/>
-      <p:regular r:id="rId10"/>
-      <p:bold r:id="rId11"/>
+      <p:regular r:id="rId12"/>
+      <p:bold r:id="rId13"/>
     </p:embeddedFont>
   </p:embeddedFontLst>
   <p:defaultTextStyle>
@@ -436,7 +438,7 @@
             <a:fld id="{1D8BD707-D9CF-40AE-B4C6-C98DA3205C09}" type="datetimeFigureOut">
               <a:rPr lang="en-US" smtClean="0"/>
               <a:pPr/>
-              <a:t>9/5/2026</a:t>
+              <a:t>9/24/2026</a:t>
             </a:fld>
             <a:endParaRPr lang="en-US"/>
           </a:p>
@@ -601,7 +603,7 @@
             <a:fld id="{1D8BD707-D9CF-40AE-B4C6-C98DA3205C09}" type="datetimeFigureOut">
               <a:rPr lang="en-US" smtClean="0"/>
               <a:pPr/>
-              <a:t>9/5/2026</a:t>
+              <a:t>9/24/2026</a:t>
             </a:fld>
             <a:endParaRPr lang="en-US"/>
           </a:p>
@@ -776,7 +778,7 @@
             <a:fld id="{1D8BD707-D9CF-40AE-B4C6-C98DA3205C09}" type="datetimeFigureOut">
               <a:rPr lang="en-US" smtClean="0"/>
               <a:pPr/>
-              <a:t>9/5/2026</a:t>
+              <a:t>9/24/2026</a:t>
             </a:fld>
             <a:endParaRPr lang="en-US"/>
           </a:p>
@@ -941,7 +943,7 @@
             <a:fld id="{1D8BD707-D9CF-40AE-B4C6-C98DA3205C09}" type="datetimeFigureOut">
               <a:rPr lang="en-US" smtClean="0"/>
               <a:pPr/>
-              <a:t>9/5/2026</a:t>
+              <a:t>9/24/2026</a:t>
             </a:fld>
             <a:endParaRPr lang="en-US"/>
           </a:p>
@@ -1183,7 +1185,7 @@
             <a:fld id="{1D8BD707-D9CF-40AE-B4C6-C98DA3205C09}" type="datetimeFigureOut">
               <a:rPr lang="en-US" smtClean="0"/>
               <a:pPr/>
-              <a:t>9/5/2026</a:t>
+              <a:t>9/24/2026</a:t>
             </a:fld>
             <a:endParaRPr lang="en-US"/>
           </a:p>
@@ -1465,7 +1467,7 @@
             <a:fld id="{1D8BD707-D9CF-40AE-B4C6-C98DA3205C09}" type="datetimeFigureOut">
               <a:rPr lang="en-US" smtClean="0"/>
               <a:pPr/>
-              <a:t>9/5/2026</a:t>
+              <a:t>9/24/2026</a:t>
             </a:fld>
             <a:endParaRPr lang="en-US"/>
           </a:p>
@@ -1881,7 +1883,7 @@
             <a:fld id="{1D8BD707-D9CF-40AE-B4C6-C98DA3205C09}" type="datetimeFigureOut">
               <a:rPr lang="en-US" smtClean="0"/>
               <a:pPr/>
-              <a:t>9/5/2026</a:t>
+              <a:t>9/24/2026</a:t>
             </a:fld>
             <a:endParaRPr lang="en-US"/>
           </a:p>
@@ -1995,7 +1997,7 @@
             <a:fld id="{1D8BD707-D9CF-40AE-B4C6-C98DA3205C09}" type="datetimeFigureOut">
               <a:rPr lang="en-US" smtClean="0"/>
               <a:pPr/>
-              <a:t>9/5/2026</a:t>
+              <a:t>9/24/2026</a:t>
             </a:fld>
             <a:endParaRPr lang="en-US"/>
           </a:p>
@@ -2087,7 +2089,7 @@
             <a:fld id="{1D8BD707-D9CF-40AE-B4C6-C98DA3205C09}" type="datetimeFigureOut">
               <a:rPr lang="en-US" smtClean="0"/>
               <a:pPr/>
-              <a:t>9/5/2026</a:t>
+              <a:t>9/24/2026</a:t>
             </a:fld>
             <a:endParaRPr lang="en-US"/>
           </a:p>
@@ -2359,7 +2361,7 @@
             <a:fld id="{1D8BD707-D9CF-40AE-B4C6-C98DA3205C09}" type="datetimeFigureOut">
               <a:rPr lang="en-US" smtClean="0"/>
               <a:pPr/>
-              <a:t>9/5/2026</a:t>
+              <a:t>9/24/2026</a:t>
             </a:fld>
             <a:endParaRPr lang="en-US"/>
           </a:p>
@@ -2608,7 +2610,7 @@
             <a:fld id="{1D8BD707-D9CF-40AE-B4C6-C98DA3205C09}" type="datetimeFigureOut">
               <a:rPr lang="en-US" smtClean="0"/>
               <a:pPr/>
-              <a:t>9/5/2026</a:t>
+              <a:t>9/24/2026</a:t>
             </a:fld>
             <a:endParaRPr lang="en-US"/>
           </a:p>
@@ -2816,7 +2818,7 @@
             <a:fld id="{1D8BD707-D9CF-40AE-B4C6-C98DA3205C09}" type="datetimeFigureOut">
               <a:rPr lang="en-US" smtClean="0"/>
               <a:pPr/>
-              <a:t>9/5/2026</a:t>
+              <a:t>9/24/2026</a:t>
             </a:fld>
             <a:endParaRPr lang="en-US"/>
           </a:p>
@@ -3304,6 +3306,138 @@
 </p:sld>
 </file>
 
+<file path=ppt/slides/slide10.xml><?xml version="1.0" encoding="utf-8"?>
+<p:sld xmlns:a="http://schemas.openxmlformats.org/drawingml/2006/main" xmlns:r="http://schemas.openxmlformats.org/officeDocument/2006/relationships" xmlns:p="http://schemas.openxmlformats.org/presentationml/2006/main">
+  <p:cSld>
+    <p:spTree>
+      <p:nvGrpSpPr>
+        <p:cNvPr id="1" name=""/>
+        <p:cNvGrpSpPr/>
+        <p:nvPr/>
+      </p:nvGrpSpPr>
+      <p:grpSpPr>
+        <a:xfrm>
+          <a:off x="0" y="0"/>
+          <a:ext cx="0" cy="0"/>
+          <a:chOff x="0" y="0"/>
+          <a:chExt cx="0" cy="0"/>
+        </a:xfrm>
+      </p:grpSpPr>
+      <p:sp>
+        <p:nvSpPr>
+          <p:cNvPr id="2" name="TextBox 2"/>
+          <p:cNvSpPr txBox="1"/>
+          <p:nvPr/>
+        </p:nvSpPr>
+        <p:spPr>
+          <a:xfrm>
+            <a:off x="2780315" y="1427444"/>
+            <a:ext cx="6135085" cy="615553"/>
+          </a:xfrm>
+          <a:prstGeom prst="rect">
+            <a:avLst/>
+          </a:prstGeom>
+        </p:spPr>
+        <p:txBody>
+          <a:bodyPr wrap="square" lIns="0" tIns="0" rIns="0" bIns="0" rtlCol="0" anchor="t">
+            <a:spAutoFit/>
+          </a:bodyPr>
+          <a:lstStyle/>
+          <a:p>
+            <a:r>
+              <a:rPr sz="4000">
+                <a:latin typeface="Times New Roman" panose="02020603050405020304" pitchFamily="18" charset="0"/>
+                <a:cs typeface="Times New Roman" panose="02020603050405020304" pitchFamily="18" charset="0"/>
+              </a:rPr>
+              <a:t>Chapter 10 Summary</a:t>
+            </a:r>
+          </a:p>
+        </p:txBody>
+      </p:sp>
+      <p:sp>
+        <p:nvSpPr>
+          <p:cNvPr id="3" name="TextBox 3"/>
+          <p:cNvSpPr txBox="1"/>
+          <p:nvPr/>
+        </p:nvSpPr>
+        <p:spPr>
+          <a:xfrm>
+            <a:off x="2860732" y="3683403"/>
+            <a:ext cx="12558283" cy="3231654"/>
+          </a:xfrm>
+          <a:prstGeom prst="rect">
+            <a:avLst/>
+          </a:prstGeom>
+        </p:spPr>
+        <p:txBody>
+          <a:bodyPr lIns="0" tIns="0" rIns="0" bIns="0" rtlCol="0" anchor="t">
+            <a:spAutoFit/>
+          </a:bodyPr>
+          <a:lstStyle/>
+          <a:p>
+            <a:r>
+              <a:rPr sz="3500" dirty="0">
+                <a:latin typeface="Times New Roman" panose="02020603050405020304" pitchFamily="18" charset="0"/>
+                <a:cs typeface="Times New Roman" panose="02020603050405020304" pitchFamily="18" charset="0"/>
+              </a:rPr>
+              <a:t>Use indexes and slicing to access string data.</a:t>
+            </a:r>
+          </a:p>
+          <a:p>
+            <a:r>
+              <a:rPr sz="3500" dirty="0">
+                <a:latin typeface="Times New Roman" panose="02020603050405020304" pitchFamily="18" charset="0"/>
+                <a:cs typeface="Times New Roman" panose="02020603050405020304" pitchFamily="18" charset="0"/>
+              </a:rPr>
+              <a:t>Use repetition and multiline strings.</a:t>
+            </a:r>
+          </a:p>
+          <a:p>
+            <a:r>
+              <a:rPr sz="3500" dirty="0">
+                <a:latin typeface="Times New Roman" panose="02020603050405020304" pitchFamily="18" charset="0"/>
+                <a:cs typeface="Times New Roman" panose="02020603050405020304" pitchFamily="18" charset="0"/>
+              </a:rPr>
+              <a:t>Use in and for to search and process strings.</a:t>
+            </a:r>
+          </a:p>
+          <a:p>
+            <a:r>
+              <a:rPr sz="3500" dirty="0">
+                <a:latin typeface="Times New Roman" panose="02020603050405020304" pitchFamily="18" charset="0"/>
+                <a:cs typeface="Times New Roman" panose="02020603050405020304" pitchFamily="18" charset="0"/>
+              </a:rPr>
+              <a:t>Use string methods to validate and format text.</a:t>
+            </a:r>
+          </a:p>
+          <a:p>
+            <a:r>
+              <a:rPr sz="3500" dirty="0">
+                <a:latin typeface="Times New Roman" panose="02020603050405020304" pitchFamily="18" charset="0"/>
+                <a:cs typeface="Times New Roman" panose="02020603050405020304" pitchFamily="18" charset="0"/>
+              </a:rPr>
+              <a:t>Use find(), replace(), and remove methods to edit text.</a:t>
+            </a:r>
+          </a:p>
+          <a:p>
+            <a:r>
+              <a:rPr sz="3500" dirty="0">
+                <a:latin typeface="Times New Roman" panose="02020603050405020304" pitchFamily="18" charset="0"/>
+                <a:cs typeface="Times New Roman" panose="02020603050405020304" pitchFamily="18" charset="0"/>
+              </a:rPr>
+              <a:t>Use split() and join() to move between strings and lists.</a:t>
+            </a:r>
+          </a:p>
+        </p:txBody>
+      </p:sp>
+    </p:spTree>
+  </p:cSld>
+  <p:clrMapOvr>
+    <a:masterClrMapping/>
+  </p:clrMapOvr>
+</p:sld>
+</file>
+
 <file path=ppt/slides/slide2.xml><?xml version="1.0" encoding="utf-8"?>
 <p:sld xmlns:a="http://schemas.openxmlformats.org/drawingml/2006/main" xmlns:r="http://schemas.openxmlformats.org/officeDocument/2006/relationships" xmlns:p="http://schemas.openxmlformats.org/presentationml/2006/main">
   <p:cSld>
@@ -3461,7 +3595,7 @@
         <p:spPr>
           <a:xfrm>
             <a:off x="836628" y="1920218"/>
-            <a:ext cx="9069371" cy="858377"/>
+            <a:ext cx="9069371" cy="615553"/>
           </a:xfrm>
           <a:prstGeom prst="rect">
             <a:avLst/>
@@ -3473,23 +3607,12 @@
           </a:bodyPr>
           <a:lstStyle/>
           <a:p>
-            <a:pPr marL="1122679" lvl="1" indent="-561340" algn="l">
-              <a:lnSpc>
-                <a:spcPts val="7279"/>
-              </a:lnSpc>
-              <a:buAutoNum type="arabicPeriod"/>
-            </a:pPr>
-            <a:r>
-              <a:rPr lang="en-US" sz="5199" b="1" dirty="0">
-                <a:solidFill>
-                  <a:srgbClr val="000B3D"/>
-                </a:solidFill>
-                <a:latin typeface="Times New Roman Bold"/>
-                <a:ea typeface="Times New Roman Bold"/>
-                <a:cs typeface="Times New Roman Bold"/>
-                <a:sym typeface="Times New Roman Bold"/>
-              </a:rPr>
-              <a:t>String Indexes and Slicing</a:t>
+            <a:r>
+              <a:rPr sz="4000" dirty="0">
+                <a:latin typeface="Times New Roman" panose="02020603050405020304" pitchFamily="18" charset="0"/>
+                <a:cs typeface="Times New Roman" panose="02020603050405020304" pitchFamily="18" charset="0"/>
+              </a:rPr>
+              <a:t>1. Indexes and Slicing</a:t>
             </a:r>
           </a:p>
         </p:txBody>
@@ -3774,10 +3897,10 @@
         </p:nvGrpSpPr>
         <p:grpSpPr>
           <a:xfrm>
-            <a:off x="8926893" y="2835888"/>
-            <a:ext cx="8590012" cy="5838056"/>
+            <a:off x="9652408" y="2835888"/>
+            <a:ext cx="7439194" cy="5838056"/>
             <a:chOff x="0" y="0"/>
-            <a:chExt cx="2262390" cy="1537595"/>
+            <a:chExt cx="1959294" cy="1537595"/>
           </a:xfrm>
         </p:grpSpPr>
         <p:sp>
@@ -3789,7 +3912,7 @@
           <p:spPr>
             <a:xfrm>
               <a:off x="0" y="0"/>
-              <a:ext cx="2262390" cy="1537595"/>
+              <a:ext cx="1959294" cy="1537595"/>
             </a:xfrm>
             <a:custGeom>
               <a:avLst/>
@@ -3798,41 +3921,56 @@
               <a:cxnLst/>
               <a:rect l="l" t="t" r="r" b="b"/>
               <a:pathLst>
-                <a:path w="2262390" h="1537595">
+                <a:path w="1959294" h="1537595">
                   <a:moveTo>
-                    <a:pt x="45965" y="0"/>
+                    <a:pt x="53075" y="0"/>
                   </a:moveTo>
                   <a:lnTo>
-                    <a:pt x="2216425" y="0"/>
+                    <a:pt x="1906219" y="0"/>
                   </a:lnTo>
                   <a:cubicBezTo>
-                    <a:pt x="2241811" y="0"/>
-                    <a:pt x="2262390" y="20579"/>
-                    <a:pt x="2262390" y="45965"/>
+                    <a:pt x="1920295" y="0"/>
+                    <a:pt x="1933795" y="5592"/>
+                    <a:pt x="1943749" y="15545"/>
+                  </a:cubicBezTo>
+                  <a:cubicBezTo>
+                    <a:pt x="1953702" y="25499"/>
+                    <a:pt x="1959294" y="38999"/>
+                    <a:pt x="1959294" y="53075"/>
                   </a:cubicBezTo>
                   <a:lnTo>
-                    <a:pt x="2262390" y="1491630"/>
+                    <a:pt x="1959294" y="1484520"/>
                   </a:lnTo>
                   <a:cubicBezTo>
-                    <a:pt x="2262390" y="1517016"/>
-                    <a:pt x="2241811" y="1537595"/>
-                    <a:pt x="2216425" y="1537595"/>
+                    <a:pt x="1959294" y="1498596"/>
+                    <a:pt x="1953702" y="1512096"/>
+                    <a:pt x="1943749" y="1522050"/>
+                  </a:cubicBezTo>
+                  <a:cubicBezTo>
+                    <a:pt x="1933795" y="1532003"/>
+                    <a:pt x="1920295" y="1537595"/>
+                    <a:pt x="1906219" y="1537595"/>
                   </a:cubicBezTo>
                   <a:lnTo>
-                    <a:pt x="45965" y="1537595"/>
+                    <a:pt x="53075" y="1537595"/>
                   </a:lnTo>
                   <a:cubicBezTo>
-                    <a:pt x="20579" y="1537595"/>
-                    <a:pt x="0" y="1517016"/>
-                    <a:pt x="0" y="1491630"/>
+                    <a:pt x="23763" y="1537595"/>
+                    <a:pt x="0" y="1513833"/>
+                    <a:pt x="0" y="1484520"/>
                   </a:cubicBezTo>
                   <a:lnTo>
-                    <a:pt x="0" y="45965"/>
+                    <a:pt x="0" y="53075"/>
                   </a:lnTo>
                   <a:cubicBezTo>
-                    <a:pt x="0" y="20579"/>
-                    <a:pt x="20579" y="0"/>
-                    <a:pt x="45965" y="0"/>
+                    <a:pt x="0" y="38999"/>
+                    <a:pt x="5592" y="25499"/>
+                    <a:pt x="15545" y="15545"/>
+                  </a:cubicBezTo>
+                  <a:cubicBezTo>
+                    <a:pt x="25499" y="5592"/>
+                    <a:pt x="38999" y="0"/>
+                    <a:pt x="53075" y="0"/>
                   </a:cubicBezTo>
                   <a:close/>
                 </a:path>
@@ -3859,7 +3997,7 @@
           <p:spPr>
             <a:xfrm>
               <a:off x="0" y="-57150"/>
-              <a:ext cx="2262390" cy="1594745"/>
+              <a:ext cx="1959294" cy="1594745"/>
             </a:xfrm>
             <a:prstGeom prst="rect">
               <a:avLst/>
@@ -3890,8 +4028,8 @@
         </p:nvSpPr>
         <p:spPr>
           <a:xfrm>
-            <a:off x="811611" y="1344809"/>
-            <a:ext cx="11151789" cy="858377"/>
+            <a:off x="836628" y="1920218"/>
+            <a:ext cx="9069371" cy="615553"/>
           </a:xfrm>
           <a:prstGeom prst="rect">
             <a:avLst/>
@@ -3903,46 +4041,12 @@
           </a:bodyPr>
           <a:lstStyle/>
           <a:p>
-            <a:pPr marL="561339" lvl="1" algn="l">
-              <a:lnSpc>
-                <a:spcPts val="7279"/>
-              </a:lnSpc>
-            </a:pPr>
-            <a:r>
-              <a:rPr lang="en-US" altLang="zh-TW" sz="5199" b="1" dirty="0">
-                <a:solidFill>
-                  <a:srgbClr val="000B3D"/>
-                </a:solidFill>
-                <a:latin typeface="Times New Roman Bold"/>
-                <a:ea typeface="Times New Roman Bold"/>
-                <a:cs typeface="Times New Roman Bold"/>
-                <a:sym typeface="Times New Roman Bold"/>
-              </a:rPr>
-              <a:t>2.</a:t>
-            </a:r>
-            <a:r>
-              <a:rPr lang="zh-TW" altLang="en-US" sz="5199" b="1" dirty="0">
-                <a:solidFill>
-                  <a:srgbClr val="000B3D"/>
-                </a:solidFill>
-                <a:latin typeface="Times New Roman Bold"/>
-                <a:ea typeface="Times New Roman Bold"/>
-                <a:cs typeface="Times New Roman Bold"/>
-                <a:sym typeface="Times New Roman Bold"/>
-              </a:rPr>
-              <a:t> </a:t>
-            </a:r>
-            <a:r>
-              <a:rPr lang="en-US" sz="5199" b="1" dirty="0">
-                <a:solidFill>
-                  <a:srgbClr val="000B3D"/>
-                </a:solidFill>
-                <a:latin typeface="Times New Roman Bold"/>
-                <a:ea typeface="Times New Roman Bold"/>
-                <a:cs typeface="Times New Roman Bold"/>
-                <a:sym typeface="Times New Roman Bold"/>
-              </a:rPr>
-              <a:t>Search and Loop Through Strings</a:t>
+            <a:r>
+              <a:rPr sz="4000" dirty="0">
+                <a:latin typeface="Times New Roman" panose="02020603050405020304" pitchFamily="18" charset="0"/>
+                <a:cs typeface="Times New Roman" panose="02020603050405020304" pitchFamily="18" charset="0"/>
+              </a:rPr>
+              <a:t>2. Repetition and Multiline Strings</a:t>
             </a:r>
           </a:p>
         </p:txBody>
@@ -3955,8 +4059,8 @@
         </p:nvSpPr>
         <p:spPr>
           <a:xfrm>
-            <a:off x="1261931" y="3781860"/>
-            <a:ext cx="7704832" cy="3434715"/>
+            <a:off x="1042157" y="3848100"/>
+            <a:ext cx="7704832" cy="2154436"/>
           </a:xfrm>
           <a:prstGeom prst="rect">
             <a:avLst/>
@@ -3968,60 +4072,30 @@
           </a:bodyPr>
           <a:lstStyle/>
           <a:p>
-            <a:pPr algn="l">
-              <a:lnSpc>
-                <a:spcPts val="5459"/>
-              </a:lnSpc>
-            </a:pPr>
-            <a:r>
-              <a:rPr lang="en-US" sz="3899">
-                <a:solidFill>
-                  <a:srgbClr val="000B3D"/>
-                </a:solidFill>
-                <a:latin typeface="Times New Roman"/>
-                <a:ea typeface="Times New Roman"/>
-                <a:cs typeface="Times New Roman"/>
-                <a:sym typeface="Times New Roman"/>
-              </a:rPr>
-              <a:t>Use in to search for text inside a string.</a:t>
-            </a:r>
-          </a:p>
-          <a:p>
-            <a:pPr algn="l">
-              <a:lnSpc>
-                <a:spcPts val="5459"/>
-              </a:lnSpc>
-            </a:pPr>
-            <a:r>
-              <a:rPr lang="en-US" sz="3899">
-                <a:solidFill>
-                  <a:srgbClr val="000B3D"/>
-                </a:solidFill>
-                <a:latin typeface="Times New Roman"/>
-                <a:ea typeface="Times New Roman"/>
-                <a:cs typeface="Times New Roman"/>
-                <a:sym typeface="Times New Roman"/>
-              </a:rPr>
-              <a:t>String searches are case-sensitive.</a:t>
-            </a:r>
-          </a:p>
-          <a:p>
-            <a:pPr algn="l">
-              <a:lnSpc>
-                <a:spcPts val="5459"/>
-              </a:lnSpc>
-            </a:pPr>
-            <a:r>
-              <a:rPr lang="en-US" sz="3899">
-                <a:solidFill>
-                  <a:srgbClr val="000B3D"/>
-                </a:solidFill>
-                <a:latin typeface="Times New Roman"/>
-                <a:ea typeface="Times New Roman"/>
-                <a:cs typeface="Times New Roman"/>
-                <a:sym typeface="Times New Roman"/>
-              </a:rPr>
-              <a:t>A for loop can process one character at  a time.</a:t>
+            <a:r>
+              <a:rPr sz="3500" dirty="0">
+                <a:latin typeface="Times New Roman" panose="02020603050405020304" pitchFamily="18" charset="0"/>
+                <a:cs typeface="Times New Roman" panose="02020603050405020304" pitchFamily="18" charset="0"/>
+              </a:rPr>
+              <a:t>Use * to repeat a string.</a:t>
+            </a:r>
+          </a:p>
+          <a:p>
+            <a:r>
+              <a:rPr sz="3500" dirty="0">
+                <a:latin typeface="Times New Roman" panose="02020603050405020304" pitchFamily="18" charset="0"/>
+                <a:cs typeface="Times New Roman" panose="02020603050405020304" pitchFamily="18" charset="0"/>
+              </a:rPr>
+              <a:t>Triple quotes can create a multiline string.</a:t>
+            </a:r>
+          </a:p>
+          <a:p>
+            <a:r>
+              <a:rPr sz="3500" dirty="0">
+                <a:latin typeface="Times New Roman" panose="02020603050405020304" pitchFamily="18" charset="0"/>
+                <a:cs typeface="Times New Roman" panose="02020603050405020304" pitchFamily="18" charset="0"/>
+              </a:rPr>
+              <a:t>A multiline string can continue across more than one line.</a:t>
             </a:r>
           </a:p>
         </p:txBody>
@@ -4034,8 +4108,8 @@
         </p:nvSpPr>
         <p:spPr>
           <a:xfrm>
-            <a:off x="9479673" y="3221595"/>
-            <a:ext cx="7284309" cy="5109210"/>
+            <a:off x="10557827" y="3471773"/>
+            <a:ext cx="5628356" cy="3877985"/>
           </a:xfrm>
           <a:prstGeom prst="rect">
             <a:avLst/>
@@ -4047,146 +4121,138 @@
           </a:bodyPr>
           <a:lstStyle/>
           <a:p>
-            <a:pPr algn="ctr">
-              <a:lnSpc>
-                <a:spcPts val="5039"/>
-              </a:lnSpc>
-            </a:pPr>
-            <a:r>
-              <a:rPr lang="en-US" sz="3599">
-                <a:solidFill>
-                  <a:srgbClr val="FFFFFF"/>
-                </a:solidFill>
-                <a:latin typeface="Times New Roman"/>
-                <a:ea typeface="Times New Roman"/>
-                <a:cs typeface="Times New Roman"/>
-                <a:sym typeface="Times New Roman"/>
-              </a:rPr>
-              <a:t>spam = "You’ve won a million dollars."</a:t>
-            </a:r>
-          </a:p>
-          <a:p>
-            <a:pPr algn="ctr">
-              <a:lnSpc>
-                <a:spcPts val="5039"/>
-              </a:lnSpc>
-            </a:pPr>
-            <a:endParaRPr lang="en-US" sz="3599">
+            <a:r>
+              <a:rPr sz="2800" dirty="0">
+                <a:solidFill>
+                  <a:schemeClr val="bg1"/>
+                </a:solidFill>
+                <a:latin typeface="Times New Roman" panose="02020603050405020304" pitchFamily="18" charset="0"/>
+                <a:cs typeface="Times New Roman" panose="02020603050405020304" pitchFamily="18" charset="0"/>
+              </a:rPr>
+              <a:t>print("=" * 20)</a:t>
+            </a:r>
+          </a:p>
+          <a:p>
+            <a:r>
+              <a:rPr sz="2800" dirty="0">
+                <a:solidFill>
+                  <a:schemeClr val="bg1"/>
+                </a:solidFill>
+                <a:latin typeface="Times New Roman" panose="02020603050405020304" pitchFamily="18" charset="0"/>
+                <a:cs typeface="Times New Roman" panose="02020603050405020304" pitchFamily="18" charset="0"/>
+              </a:rPr>
+              <a:t>print("A horse! " * 2)</a:t>
+            </a:r>
+          </a:p>
+          <a:p>
+            <a:endParaRPr sz="2800" dirty="0">
               <a:solidFill>
-                <a:srgbClr val="FFFFFF"/>
+                <a:schemeClr val="bg1"/>
               </a:solidFill>
-              <a:latin typeface="Times New Roman"/>
-              <a:ea typeface="Times New Roman"/>
-              <a:cs typeface="Times New Roman"/>
-              <a:sym typeface="Times New Roman"/>
+              <a:latin typeface="Times New Roman" panose="02020603050405020304" pitchFamily="18" charset="0"/>
+              <a:cs typeface="Times New Roman" panose="02020603050405020304" pitchFamily="18" charset="0"/>
             </a:endParaRPr>
           </a:p>
           <a:p>
-            <a:pPr algn="ctr">
-              <a:lnSpc>
-                <a:spcPts val="5039"/>
-              </a:lnSpc>
-            </a:pPr>
-            <a:r>
-              <a:rPr lang="en-US" sz="3599">
-                <a:solidFill>
-                  <a:srgbClr val="FFFFFF"/>
-                </a:solidFill>
-                <a:latin typeface="Times New Roman"/>
-                <a:ea typeface="Times New Roman"/>
-                <a:cs typeface="Times New Roman"/>
-                <a:sym typeface="Times New Roman"/>
-              </a:rPr>
-              <a:t>print("million" in spam)         #True</a:t>
-            </a:r>
-          </a:p>
-          <a:p>
-            <a:pPr algn="ctr">
-              <a:lnSpc>
-                <a:spcPts val="5039"/>
-              </a:lnSpc>
-            </a:pPr>
-            <a:endParaRPr lang="en-US" sz="3599">
+            <a:r>
+              <a:rPr sz="2800" dirty="0">
+                <a:solidFill>
+                  <a:schemeClr val="bg1"/>
+                </a:solidFill>
+                <a:latin typeface="Times New Roman" panose="02020603050405020304" pitchFamily="18" charset="0"/>
+                <a:cs typeface="Times New Roman" panose="02020603050405020304" pitchFamily="18" charset="0"/>
+              </a:rPr>
+              <a:t>query = '''SELECT </a:t>
+            </a:r>
+            <a:r>
+              <a:rPr sz="2800" dirty="0" err="1">
+                <a:solidFill>
+                  <a:schemeClr val="bg1"/>
+                </a:solidFill>
+                <a:latin typeface="Times New Roman" panose="02020603050405020304" pitchFamily="18" charset="0"/>
+                <a:cs typeface="Times New Roman" panose="02020603050405020304" pitchFamily="18" charset="0"/>
+              </a:rPr>
+              <a:t>categoryID</a:t>
+            </a:r>
+            <a:r>
+              <a:rPr sz="2800" dirty="0">
+                <a:solidFill>
+                  <a:schemeClr val="bg1"/>
+                </a:solidFill>
+                <a:latin typeface="Times New Roman" panose="02020603050405020304" pitchFamily="18" charset="0"/>
+                <a:cs typeface="Times New Roman" panose="02020603050405020304" pitchFamily="18" charset="0"/>
+              </a:rPr>
+              <a:t>, name AS </a:t>
+            </a:r>
+            <a:r>
+              <a:rPr sz="2800" dirty="0" err="1">
+                <a:solidFill>
+                  <a:schemeClr val="bg1"/>
+                </a:solidFill>
+                <a:latin typeface="Times New Roman" panose="02020603050405020304" pitchFamily="18" charset="0"/>
+                <a:cs typeface="Times New Roman" panose="02020603050405020304" pitchFamily="18" charset="0"/>
+              </a:rPr>
+              <a:t>categoryName</a:t>
+            </a:r>
+            <a:endParaRPr sz="2800" dirty="0">
               <a:solidFill>
-                <a:srgbClr val="FFFFFF"/>
+                <a:schemeClr val="bg1"/>
               </a:solidFill>
-              <a:latin typeface="Times New Roman"/>
-              <a:ea typeface="Times New Roman"/>
-              <a:cs typeface="Times New Roman"/>
-              <a:sym typeface="Times New Roman"/>
+              <a:latin typeface="Times New Roman" panose="02020603050405020304" pitchFamily="18" charset="0"/>
+              <a:cs typeface="Times New Roman" panose="02020603050405020304" pitchFamily="18" charset="0"/>
             </a:endParaRPr>
           </a:p>
           <a:p>
-            <a:pPr algn="ctr">
-              <a:lnSpc>
-                <a:spcPts val="5039"/>
-              </a:lnSpc>
-            </a:pPr>
-            <a:r>
-              <a:rPr lang="en-US" sz="3599">
-                <a:solidFill>
-                  <a:srgbClr val="FFFFFF"/>
-                </a:solidFill>
-                <a:latin typeface="Times New Roman"/>
-                <a:ea typeface="Times New Roman"/>
-                <a:cs typeface="Times New Roman"/>
-                <a:sym typeface="Times New Roman"/>
-              </a:rPr>
-              <a:t>message = "Hi !"</a:t>
-            </a:r>
-          </a:p>
-          <a:p>
-            <a:pPr algn="ctr">
-              <a:lnSpc>
-                <a:spcPts val="5039"/>
-              </a:lnSpc>
-            </a:pPr>
-            <a:endParaRPr lang="en-US" sz="3599">
+            <a:r>
+              <a:rPr sz="2800" dirty="0">
+                <a:solidFill>
+                  <a:schemeClr val="bg1"/>
+                </a:solidFill>
+                <a:latin typeface="Times New Roman" panose="02020603050405020304" pitchFamily="18" charset="0"/>
+                <a:cs typeface="Times New Roman" panose="02020603050405020304" pitchFamily="18" charset="0"/>
+              </a:rPr>
+              <a:t>FROM Category WHERE </a:t>
+            </a:r>
+            <a:r>
+              <a:rPr sz="2800" dirty="0" err="1">
+                <a:solidFill>
+                  <a:schemeClr val="bg1"/>
+                </a:solidFill>
+                <a:latin typeface="Times New Roman" panose="02020603050405020304" pitchFamily="18" charset="0"/>
+                <a:cs typeface="Times New Roman" panose="02020603050405020304" pitchFamily="18" charset="0"/>
+              </a:rPr>
+              <a:t>categoryID</a:t>
+            </a:r>
+            <a:r>
+              <a:rPr sz="2800" dirty="0">
+                <a:solidFill>
+                  <a:schemeClr val="bg1"/>
+                </a:solidFill>
+                <a:latin typeface="Times New Roman" panose="02020603050405020304" pitchFamily="18" charset="0"/>
+                <a:cs typeface="Times New Roman" panose="02020603050405020304" pitchFamily="18" charset="0"/>
+              </a:rPr>
+              <a:t> = ?'''</a:t>
+            </a:r>
+          </a:p>
+          <a:p>
+            <a:endParaRPr sz="2800" dirty="0">
               <a:solidFill>
-                <a:srgbClr val="FFFFFF"/>
+                <a:schemeClr val="bg1"/>
               </a:solidFill>
-              <a:latin typeface="Times New Roman"/>
-              <a:ea typeface="Times New Roman"/>
-              <a:cs typeface="Times New Roman"/>
-              <a:sym typeface="Times New Roman"/>
+              <a:latin typeface="Times New Roman" panose="02020603050405020304" pitchFamily="18" charset="0"/>
+              <a:cs typeface="Times New Roman" panose="02020603050405020304" pitchFamily="18" charset="0"/>
             </a:endParaRPr>
           </a:p>
           <a:p>
-            <a:pPr algn="ctr">
-              <a:lnSpc>
-                <a:spcPts val="5039"/>
-              </a:lnSpc>
-            </a:pPr>
-            <a:r>
-              <a:rPr lang="en-US" sz="3599">
-                <a:solidFill>
-                  <a:srgbClr val="FFFFFF"/>
-                </a:solidFill>
-                <a:latin typeface="Times New Roman"/>
-                <a:ea typeface="Times New Roman"/>
-                <a:cs typeface="Times New Roman"/>
-                <a:sym typeface="Times New Roman"/>
-              </a:rPr>
-              <a:t>for char in message:</a:t>
-            </a:r>
-          </a:p>
-          <a:p>
-            <a:pPr algn="ctr">
-              <a:lnSpc>
-                <a:spcPts val="5039"/>
-              </a:lnSpc>
-            </a:pPr>
-            <a:r>
-              <a:rPr lang="en-US" sz="3599">
-                <a:solidFill>
-                  <a:srgbClr val="FFFFFF"/>
-                </a:solidFill>
-                <a:latin typeface="Times New Roman"/>
-                <a:ea typeface="Times New Roman"/>
-                <a:cs typeface="Times New Roman"/>
-                <a:sym typeface="Times New Roman"/>
-              </a:rPr>
-              <a:t>print(char)</a:t>
+            <a:r>
+              <a:rPr sz="2800" dirty="0">
+                <a:solidFill>
+                  <a:schemeClr val="bg1"/>
+                </a:solidFill>
+                <a:latin typeface="Times New Roman" panose="02020603050405020304" pitchFamily="18" charset="0"/>
+                <a:cs typeface="Times New Roman" panose="02020603050405020304" pitchFamily="18" charset="0"/>
+              </a:rPr>
+              <a:t>print(query)</a:t>
             </a:r>
           </a:p>
         </p:txBody>
@@ -4340,8 +4406,8 @@
         </p:nvSpPr>
         <p:spPr>
           <a:xfrm>
-            <a:off x="811610" y="1344809"/>
-            <a:ext cx="8027589" cy="858377"/>
+            <a:off x="811611" y="1344809"/>
+            <a:ext cx="11151789" cy="615553"/>
           </a:xfrm>
           <a:prstGeom prst="rect">
             <a:avLst/>
@@ -4353,46 +4419,357 @@
           </a:bodyPr>
           <a:lstStyle/>
           <a:p>
-            <a:pPr marL="561339" lvl="1" algn="l">
-              <a:lnSpc>
-                <a:spcPts val="7279"/>
-              </a:lnSpc>
-            </a:pPr>
-            <a:r>
-              <a:rPr lang="en-US" altLang="zh-TW" sz="5199" b="1" dirty="0">
-                <a:solidFill>
-                  <a:srgbClr val="000B3D"/>
-                </a:solidFill>
-                <a:latin typeface="Times New Roman Bold"/>
-                <a:ea typeface="Times New Roman Bold"/>
-                <a:cs typeface="Times New Roman Bold"/>
-                <a:sym typeface="Times New Roman Bold"/>
-              </a:rPr>
-              <a:t>3.</a:t>
-            </a:r>
-            <a:r>
-              <a:rPr lang="zh-TW" altLang="en-US" sz="5199" b="1" dirty="0">
-                <a:solidFill>
-                  <a:srgbClr val="000B3D"/>
-                </a:solidFill>
-                <a:latin typeface="Times New Roman Bold"/>
-                <a:ea typeface="Times New Roman Bold"/>
-                <a:cs typeface="Times New Roman Bold"/>
-                <a:sym typeface="Times New Roman Bold"/>
-              </a:rPr>
-              <a:t> </a:t>
-            </a:r>
-            <a:r>
-              <a:rPr lang="en-US" sz="5199" b="1" dirty="0">
-                <a:solidFill>
-                  <a:srgbClr val="000B3D"/>
-                </a:solidFill>
-                <a:latin typeface="Times New Roman Bold"/>
-                <a:ea typeface="Times New Roman Bold"/>
-                <a:cs typeface="Times New Roman Bold"/>
-                <a:sym typeface="Times New Roman Bold"/>
-              </a:rPr>
-              <a:t>Basic String Methods</a:t>
+            <a:r>
+              <a:rPr sz="4000" dirty="0">
+                <a:latin typeface="Times New Roman" panose="02020603050405020304" pitchFamily="18" charset="0"/>
+                <a:cs typeface="Times New Roman" panose="02020603050405020304" pitchFamily="18" charset="0"/>
+              </a:rPr>
+              <a:t>3. Search and Loop Through Strings</a:t>
+            </a:r>
+          </a:p>
+        </p:txBody>
+      </p:sp>
+      <p:sp>
+        <p:nvSpPr>
+          <p:cNvPr id="6" name="TextBox 6"/>
+          <p:cNvSpPr txBox="1"/>
+          <p:nvPr/>
+        </p:nvSpPr>
+        <p:spPr>
+          <a:xfrm>
+            <a:off x="1143000" y="3771900"/>
+            <a:ext cx="7704832" cy="2154436"/>
+          </a:xfrm>
+          <a:prstGeom prst="rect">
+            <a:avLst/>
+          </a:prstGeom>
+        </p:spPr>
+        <p:txBody>
+          <a:bodyPr lIns="0" tIns="0" rIns="0" bIns="0" rtlCol="0" anchor="t">
+            <a:spAutoFit/>
+          </a:bodyPr>
+          <a:lstStyle/>
+          <a:p>
+            <a:r>
+              <a:rPr sz="3500" dirty="0">
+                <a:latin typeface="Times New Roman" panose="02020603050405020304" pitchFamily="18" charset="0"/>
+                <a:cs typeface="Times New Roman" panose="02020603050405020304" pitchFamily="18" charset="0"/>
+              </a:rPr>
+              <a:t>Use in to search for text inside a string.</a:t>
+            </a:r>
+          </a:p>
+          <a:p>
+            <a:r>
+              <a:rPr sz="3500" dirty="0">
+                <a:latin typeface="Times New Roman" panose="02020603050405020304" pitchFamily="18" charset="0"/>
+                <a:cs typeface="Times New Roman" panose="02020603050405020304" pitchFamily="18" charset="0"/>
+              </a:rPr>
+              <a:t>String searches are case-sensitive.</a:t>
+            </a:r>
+          </a:p>
+          <a:p>
+            <a:r>
+              <a:rPr sz="3500" dirty="0">
+                <a:latin typeface="Times New Roman" panose="02020603050405020304" pitchFamily="18" charset="0"/>
+                <a:cs typeface="Times New Roman" panose="02020603050405020304" pitchFamily="18" charset="0"/>
+              </a:rPr>
+              <a:t>A for loop can process one character at a time.</a:t>
+            </a:r>
+          </a:p>
+        </p:txBody>
+      </p:sp>
+      <p:sp>
+        <p:nvSpPr>
+          <p:cNvPr id="7" name="TextBox 7"/>
+          <p:cNvSpPr txBox="1"/>
+          <p:nvPr/>
+        </p:nvSpPr>
+        <p:spPr>
+          <a:xfrm>
+            <a:off x="9479673" y="3221595"/>
+            <a:ext cx="7284309" cy="4616648"/>
+          </a:xfrm>
+          <a:prstGeom prst="rect">
+            <a:avLst/>
+          </a:prstGeom>
+        </p:spPr>
+        <p:txBody>
+          <a:bodyPr lIns="0" tIns="0" rIns="0" bIns="0" rtlCol="0" anchor="t">
+            <a:spAutoFit/>
+          </a:bodyPr>
+          <a:lstStyle/>
+          <a:p>
+            <a:r>
+              <a:rPr sz="3000" dirty="0">
+                <a:solidFill>
+                  <a:schemeClr val="bg1"/>
+                </a:solidFill>
+                <a:latin typeface="Times New Roman" panose="02020603050405020304" pitchFamily="18" charset="0"/>
+                <a:cs typeface="Times New Roman" panose="02020603050405020304" pitchFamily="18" charset="0"/>
+              </a:rPr>
+              <a:t>spam = "Congratulations. You've won a million dollars."</a:t>
+            </a:r>
+          </a:p>
+          <a:p>
+            <a:endParaRPr sz="3000" dirty="0">
+              <a:solidFill>
+                <a:schemeClr val="bg1"/>
+              </a:solidFill>
+              <a:latin typeface="Times New Roman" panose="02020603050405020304" pitchFamily="18" charset="0"/>
+              <a:cs typeface="Times New Roman" panose="02020603050405020304" pitchFamily="18" charset="0"/>
+            </a:endParaRPr>
+          </a:p>
+          <a:p>
+            <a:r>
+              <a:rPr sz="3000" dirty="0">
+                <a:solidFill>
+                  <a:schemeClr val="bg1"/>
+                </a:solidFill>
+                <a:latin typeface="Times New Roman" panose="02020603050405020304" pitchFamily="18" charset="0"/>
+                <a:cs typeface="Times New Roman" panose="02020603050405020304" pitchFamily="18" charset="0"/>
+              </a:rPr>
+              <a:t>print("million" in spam)</a:t>
+            </a:r>
+          </a:p>
+          <a:p>
+            <a:r>
+              <a:rPr sz="3000" dirty="0">
+                <a:solidFill>
+                  <a:schemeClr val="bg1"/>
+                </a:solidFill>
+                <a:latin typeface="Times New Roman" panose="02020603050405020304" pitchFamily="18" charset="0"/>
+                <a:cs typeface="Times New Roman" panose="02020603050405020304" pitchFamily="18" charset="0"/>
+              </a:rPr>
+              <a:t>print("Million" in spam)</a:t>
+            </a:r>
+          </a:p>
+          <a:p>
+            <a:r>
+              <a:rPr sz="3000" dirty="0">
+                <a:solidFill>
+                  <a:schemeClr val="bg1"/>
+                </a:solidFill>
+                <a:latin typeface="Times New Roman" panose="02020603050405020304" pitchFamily="18" charset="0"/>
+                <a:cs typeface="Times New Roman" panose="02020603050405020304" pitchFamily="18" charset="0"/>
+              </a:rPr>
+              <a:t>print("on" in spam)</a:t>
+            </a:r>
+          </a:p>
+          <a:p>
+            <a:endParaRPr sz="3000" dirty="0">
+              <a:solidFill>
+                <a:schemeClr val="bg1"/>
+              </a:solidFill>
+              <a:latin typeface="Times New Roman" panose="02020603050405020304" pitchFamily="18" charset="0"/>
+              <a:cs typeface="Times New Roman" panose="02020603050405020304" pitchFamily="18" charset="0"/>
+            </a:endParaRPr>
+          </a:p>
+          <a:p>
+            <a:r>
+              <a:rPr sz="3000" dirty="0">
+                <a:solidFill>
+                  <a:schemeClr val="bg1"/>
+                </a:solidFill>
+                <a:latin typeface="Times New Roman" panose="02020603050405020304" pitchFamily="18" charset="0"/>
+                <a:cs typeface="Times New Roman" panose="02020603050405020304" pitchFamily="18" charset="0"/>
+              </a:rPr>
+              <a:t>message = "Hi!"</a:t>
+            </a:r>
+          </a:p>
+          <a:p>
+            <a:r>
+              <a:rPr sz="3000" dirty="0">
+                <a:solidFill>
+                  <a:schemeClr val="bg1"/>
+                </a:solidFill>
+                <a:latin typeface="Times New Roman" panose="02020603050405020304" pitchFamily="18" charset="0"/>
+                <a:cs typeface="Times New Roman" panose="02020603050405020304" pitchFamily="18" charset="0"/>
+              </a:rPr>
+              <a:t>for char in message:</a:t>
+            </a:r>
+          </a:p>
+          <a:p>
+            <a:r>
+              <a:rPr sz="3000" dirty="0">
+                <a:solidFill>
+                  <a:schemeClr val="bg1"/>
+                </a:solidFill>
+                <a:latin typeface="Times New Roman" panose="02020603050405020304" pitchFamily="18" charset="0"/>
+                <a:cs typeface="Times New Roman" panose="02020603050405020304" pitchFamily="18" charset="0"/>
+              </a:rPr>
+              <a:t>    print(char)</a:t>
+            </a:r>
+          </a:p>
+        </p:txBody>
+      </p:sp>
+    </p:spTree>
+  </p:cSld>
+  <p:clrMapOvr>
+    <a:masterClrMapping/>
+  </p:clrMapOvr>
+</p:sld>
+</file>
+
+<file path=ppt/slides/slide5.xml><?xml version="1.0" encoding="utf-8"?>
+<p:sld xmlns:a="http://schemas.openxmlformats.org/drawingml/2006/main" xmlns:r="http://schemas.openxmlformats.org/officeDocument/2006/relationships" xmlns:p="http://schemas.openxmlformats.org/presentationml/2006/main">
+  <p:cSld>
+    <p:spTree>
+      <p:nvGrpSpPr>
+        <p:cNvPr id="1" name=""/>
+        <p:cNvGrpSpPr/>
+        <p:nvPr/>
+      </p:nvGrpSpPr>
+      <p:grpSpPr>
+        <a:xfrm>
+          <a:off x="0" y="0"/>
+          <a:ext cx="0" cy="0"/>
+          <a:chOff x="0" y="0"/>
+          <a:chExt cx="0" cy="0"/>
+        </a:xfrm>
+      </p:grpSpPr>
+      <p:grpSp>
+        <p:nvGrpSpPr>
+          <p:cNvPr id="2" name="Group 2"/>
+          <p:cNvGrpSpPr/>
+          <p:nvPr/>
+        </p:nvGrpSpPr>
+        <p:grpSpPr>
+          <a:xfrm>
+            <a:off x="8926893" y="2835888"/>
+            <a:ext cx="8590012" cy="5838056"/>
+            <a:chOff x="0" y="0"/>
+            <a:chExt cx="2262390" cy="1537595"/>
+          </a:xfrm>
+        </p:grpSpPr>
+        <p:sp>
+          <p:nvSpPr>
+            <p:cNvPr id="3" name="Freeform 3"/>
+            <p:cNvSpPr/>
+            <p:nvPr/>
+          </p:nvSpPr>
+          <p:spPr>
+            <a:xfrm>
+              <a:off x="0" y="0"/>
+              <a:ext cx="2262390" cy="1537595"/>
+            </a:xfrm>
+            <a:custGeom>
+              <a:avLst/>
+              <a:gdLst/>
+              <a:ahLst/>
+              <a:cxnLst/>
+              <a:rect l="l" t="t" r="r" b="b"/>
+              <a:pathLst>
+                <a:path w="2262390" h="1537595">
+                  <a:moveTo>
+                    <a:pt x="45965" y="0"/>
+                  </a:moveTo>
+                  <a:lnTo>
+                    <a:pt x="2216425" y="0"/>
+                  </a:lnTo>
+                  <a:cubicBezTo>
+                    <a:pt x="2241811" y="0"/>
+                    <a:pt x="2262390" y="20579"/>
+                    <a:pt x="2262390" y="45965"/>
+                  </a:cubicBezTo>
+                  <a:lnTo>
+                    <a:pt x="2262390" y="1491630"/>
+                  </a:lnTo>
+                  <a:cubicBezTo>
+                    <a:pt x="2262390" y="1517016"/>
+                    <a:pt x="2241811" y="1537595"/>
+                    <a:pt x="2216425" y="1537595"/>
+                  </a:cubicBezTo>
+                  <a:lnTo>
+                    <a:pt x="45965" y="1537595"/>
+                  </a:lnTo>
+                  <a:cubicBezTo>
+                    <a:pt x="20579" y="1537595"/>
+                    <a:pt x="0" y="1517016"/>
+                    <a:pt x="0" y="1491630"/>
+                  </a:cubicBezTo>
+                  <a:lnTo>
+                    <a:pt x="0" y="45965"/>
+                  </a:lnTo>
+                  <a:cubicBezTo>
+                    <a:pt x="0" y="20579"/>
+                    <a:pt x="20579" y="0"/>
+                    <a:pt x="45965" y="0"/>
+                  </a:cubicBezTo>
+                  <a:close/>
+                </a:path>
+              </a:pathLst>
+            </a:custGeom>
+            <a:solidFill>
+              <a:srgbClr val="000B3D"/>
+            </a:solidFill>
+          </p:spPr>
+          <p:txBody>
+            <a:bodyPr/>
+            <a:lstStyle/>
+            <a:p>
+              <a:endParaRPr lang="zh-TW" altLang="en-US"/>
+            </a:p>
+          </p:txBody>
+        </p:sp>
+        <p:sp>
+          <p:nvSpPr>
+            <p:cNvPr id="4" name="TextBox 4"/>
+            <p:cNvSpPr txBox="1"/>
+            <p:nvPr/>
+          </p:nvSpPr>
+          <p:spPr>
+            <a:xfrm>
+              <a:off x="0" y="-57150"/>
+              <a:ext cx="2262390" cy="1594745"/>
+            </a:xfrm>
+            <a:prstGeom prst="rect">
+              <a:avLst/>
+            </a:prstGeom>
+          </p:spPr>
+          <p:txBody>
+            <a:bodyPr lIns="50800" tIns="50800" rIns="50800" bIns="50800" rtlCol="0" anchor="ctr"/>
+            <a:lstStyle/>
+            <a:p>
+              <a:pPr algn="ctr">
+                <a:lnSpc>
+                  <a:spcPts val="2659"/>
+                </a:lnSpc>
+                <a:spcBef>
+                  <a:spcPct val="0"/>
+                </a:spcBef>
+              </a:pPr>
+              <a:endParaRPr/>
+            </a:p>
+          </p:txBody>
+        </p:sp>
+      </p:grpSp>
+      <p:sp>
+        <p:nvSpPr>
+          <p:cNvPr id="5" name="TextBox 5"/>
+          <p:cNvSpPr txBox="1"/>
+          <p:nvPr/>
+        </p:nvSpPr>
+        <p:spPr>
+          <a:xfrm>
+            <a:off x="811610" y="1344809"/>
+            <a:ext cx="8027589" cy="615553"/>
+          </a:xfrm>
+          <a:prstGeom prst="rect">
+            <a:avLst/>
+          </a:prstGeom>
+        </p:spPr>
+        <p:txBody>
+          <a:bodyPr wrap="square" lIns="0" tIns="0" rIns="0" bIns="0" rtlCol="0" anchor="t">
+            <a:spAutoFit/>
+          </a:bodyPr>
+          <a:lstStyle/>
+          <a:p>
+            <a:r>
+              <a:rPr sz="4000" dirty="0">
+                <a:latin typeface="Times New Roman" panose="02020603050405020304" pitchFamily="18" charset="0"/>
+                <a:cs typeface="Times New Roman" panose="02020603050405020304" pitchFamily="18" charset="0"/>
+              </a:rPr>
+              <a:t>4. Basic String Methods</a:t>
             </a:r>
           </a:p>
         </p:txBody>
@@ -4690,7 +5067,7 @@
 </p:sld>
 </file>
 
-<file path=ppt/slides/slide5.xml><?xml version="1.0" encoding="utf-8"?>
+<file path=ppt/slides/slide6.xml><?xml version="1.0" encoding="utf-8"?>
 <p:sld xmlns:a="http://schemas.openxmlformats.org/drawingml/2006/main" xmlns:r="http://schemas.openxmlformats.org/officeDocument/2006/relationships" xmlns:p="http://schemas.openxmlformats.org/presentationml/2006/main">
   <p:cSld>
     <p:spTree>
@@ -4832,7 +5209,7 @@
         <p:spPr>
           <a:xfrm>
             <a:off x="811610" y="1344809"/>
-            <a:ext cx="9322989" cy="858377"/>
+            <a:ext cx="9322989" cy="615553"/>
           </a:xfrm>
           <a:prstGeom prst="rect">
             <a:avLst/>
@@ -4844,46 +5221,12 @@
           </a:bodyPr>
           <a:lstStyle/>
           <a:p>
-            <a:pPr marL="561339" lvl="1" algn="l">
-              <a:lnSpc>
-                <a:spcPts val="7279"/>
-              </a:lnSpc>
-            </a:pPr>
-            <a:r>
-              <a:rPr lang="en-US" altLang="zh-TW" sz="5199" b="1" dirty="0">
-                <a:solidFill>
-                  <a:srgbClr val="000B3D"/>
-                </a:solidFill>
-                <a:latin typeface="Times New Roman Bold"/>
-                <a:ea typeface="Times New Roman Bold"/>
-                <a:cs typeface="Times New Roman Bold"/>
-                <a:sym typeface="Times New Roman Bold"/>
-              </a:rPr>
-              <a:t>4.</a:t>
-            </a:r>
-            <a:r>
-              <a:rPr lang="zh-TW" altLang="en-US" sz="5199" b="1" dirty="0">
-                <a:solidFill>
-                  <a:srgbClr val="000B3D"/>
-                </a:solidFill>
-                <a:latin typeface="Times New Roman Bold"/>
-                <a:ea typeface="Times New Roman Bold"/>
-                <a:cs typeface="Times New Roman Bold"/>
-                <a:sym typeface="Times New Roman Bold"/>
-              </a:rPr>
-              <a:t> </a:t>
-            </a:r>
-            <a:r>
-              <a:rPr lang="en-US" sz="5199" b="1" dirty="0">
-                <a:solidFill>
-                  <a:srgbClr val="000B3D"/>
-                </a:solidFill>
-                <a:latin typeface="Times New Roman Bold"/>
-                <a:ea typeface="Times New Roman Bold"/>
-                <a:cs typeface="Times New Roman Bold"/>
-                <a:sym typeface="Times New Roman Bold"/>
-              </a:rPr>
-              <a:t>Find, Replace, and Remove</a:t>
+            <a:r>
+              <a:rPr sz="4000">
+                <a:latin typeface="Times New Roman" panose="02020603050405020304" pitchFamily="18" charset="0"/>
+                <a:cs typeface="Times New Roman" panose="02020603050405020304" pitchFamily="18" charset="0"/>
+              </a:rPr>
+              <a:t>5. Find, Replace, and Remove</a:t>
             </a:r>
           </a:p>
         </p:txBody>
@@ -4915,7 +5258,7 @@
               </a:lnSpc>
             </a:pPr>
             <a:r>
-              <a:rPr lang="en-US" sz="3999">
+              <a:rPr lang="en-US" sz="3999" dirty="0">
                 <a:solidFill>
                   <a:srgbClr val="000B3D"/>
                 </a:solidFill>
@@ -4934,7 +5277,7 @@
               </a:lnSpc>
             </a:pPr>
             <a:r>
-              <a:rPr lang="en-US" sz="3999">
+              <a:rPr lang="en-US" sz="3999" dirty="0">
                 <a:solidFill>
                   <a:srgbClr val="000B3D"/>
                 </a:solidFill>
@@ -4953,7 +5296,7 @@
               </a:lnSpc>
             </a:pPr>
             <a:r>
-              <a:rPr lang="en-US" sz="3999">
+              <a:rPr lang="en-US" sz="3999" dirty="0">
                 <a:solidFill>
                   <a:srgbClr val="000B3D"/>
                 </a:solidFill>
@@ -4972,7 +5315,7 @@
               </a:lnSpc>
             </a:pPr>
             <a:r>
-              <a:rPr lang="en-US" sz="3999">
+              <a:rPr lang="en-US" sz="3999" dirty="0" err="1">
                 <a:solidFill>
                   <a:srgbClr val="000B3D"/>
                 </a:solidFill>
@@ -4981,7 +5324,43 @@
                 <a:cs typeface="Times New Roman"/>
                 <a:sym typeface="Times New Roman"/>
               </a:rPr>
-              <a:t>removeprefix() and removesuffix() remove text from the ends.</a:t>
+              <a:t>removeprefix</a:t>
+            </a:r>
+            <a:r>
+              <a:rPr lang="en-US" sz="3999" dirty="0">
+                <a:solidFill>
+                  <a:srgbClr val="000B3D"/>
+                </a:solidFill>
+                <a:latin typeface="Times New Roman"/>
+                <a:ea typeface="Times New Roman"/>
+                <a:cs typeface="Times New Roman"/>
+                <a:sym typeface="Times New Roman"/>
+              </a:rPr>
+              <a:t>() and </a:t>
+            </a:r>
+            <a:r>
+              <a:rPr lang="en-US" sz="3999" dirty="0" err="1">
+                <a:solidFill>
+                  <a:srgbClr val="000B3D"/>
+                </a:solidFill>
+                <a:latin typeface="Times New Roman"/>
+                <a:ea typeface="Times New Roman"/>
+                <a:cs typeface="Times New Roman"/>
+                <a:sym typeface="Times New Roman"/>
+              </a:rPr>
+              <a:t>removesuffix</a:t>
+            </a:r>
+            <a:r>
+              <a:rPr lang="en-US" sz="3999" dirty="0">
+                <a:solidFill>
+                  <a:srgbClr val="000B3D"/>
+                </a:solidFill>
+                <a:latin typeface="Times New Roman"/>
+                <a:ea typeface="Times New Roman"/>
+                <a:cs typeface="Times New Roman"/>
+                <a:sym typeface="Times New Roman"/>
+              </a:rPr>
+              <a:t>() remove text from the ends.</a:t>
             </a:r>
           </a:p>
         </p:txBody>
@@ -4995,7 +5374,7 @@
         <p:spPr>
           <a:xfrm>
             <a:off x="9479673" y="3221595"/>
-            <a:ext cx="7284309" cy="5747385"/>
+            <a:ext cx="7284309" cy="4616648"/>
           </a:xfrm>
           <a:prstGeom prst="rect">
             <a:avLst/>
@@ -5007,168 +5386,245 @@
           </a:bodyPr>
           <a:lstStyle/>
           <a:p>
-            <a:pPr algn="ctr">
-              <a:lnSpc>
-                <a:spcPts val="5039"/>
-              </a:lnSpc>
-            </a:pPr>
-            <a:r>
-              <a:rPr lang="en-US" sz="3599">
-                <a:solidFill>
-                  <a:srgbClr val="FFFFFF"/>
-                </a:solidFill>
-                <a:latin typeface="Times New Roman"/>
-                <a:ea typeface="Times New Roman"/>
-                <a:cs typeface="Times New Roman"/>
-                <a:sym typeface="Times New Roman"/>
-              </a:rPr>
-              <a:t>email = "joel.murach@com"</a:t>
-            </a:r>
-          </a:p>
-          <a:p>
-            <a:pPr algn="ctr">
-              <a:lnSpc>
-                <a:spcPts val="5039"/>
-              </a:lnSpc>
-            </a:pPr>
-            <a:r>
-              <a:rPr lang="en-US" sz="3599">
-                <a:solidFill>
-                  <a:srgbClr val="FFFFFF"/>
-                </a:solidFill>
-                <a:latin typeface="Times New Roman"/>
-                <a:ea typeface="Times New Roman"/>
-                <a:cs typeface="Times New Roman"/>
-                <a:sym typeface="Times New Roman"/>
-              </a:rPr>
-              <a:t>print(email.find("@"))        # 11</a:t>
-            </a:r>
-          </a:p>
-          <a:p>
-            <a:pPr algn="ctr">
-              <a:lnSpc>
-                <a:spcPts val="5039"/>
-              </a:lnSpc>
-            </a:pPr>
-            <a:endParaRPr lang="en-US" sz="3599">
+            <a:r>
+              <a:rPr sz="3000" dirty="0">
+                <a:solidFill>
+                  <a:schemeClr val="bg1"/>
+                </a:solidFill>
+                <a:latin typeface="Times New Roman" panose="02020603050405020304" pitchFamily="18" charset="0"/>
+                <a:cs typeface="Times New Roman" panose="02020603050405020304" pitchFamily="18" charset="0"/>
+              </a:rPr>
+              <a:t>email = "</a:t>
+            </a:r>
+            <a:r>
+              <a:rPr sz="3000" dirty="0" err="1">
+                <a:solidFill>
+                  <a:schemeClr val="bg1"/>
+                </a:solidFill>
+                <a:latin typeface="Times New Roman" panose="02020603050405020304" pitchFamily="18" charset="0"/>
+                <a:cs typeface="Times New Roman" panose="02020603050405020304" pitchFamily="18" charset="0"/>
+              </a:rPr>
+              <a:t>joel.murach@com</a:t>
+            </a:r>
+            <a:r>
+              <a:rPr sz="3000" dirty="0">
+                <a:solidFill>
+                  <a:schemeClr val="bg1"/>
+                </a:solidFill>
+                <a:latin typeface="Times New Roman" panose="02020603050405020304" pitchFamily="18" charset="0"/>
+                <a:cs typeface="Times New Roman" panose="02020603050405020304" pitchFamily="18" charset="0"/>
+              </a:rPr>
+              <a:t>"</a:t>
+            </a:r>
+          </a:p>
+          <a:p>
+            <a:r>
+              <a:rPr sz="3000" dirty="0">
+                <a:solidFill>
+                  <a:schemeClr val="bg1"/>
+                </a:solidFill>
+                <a:latin typeface="Times New Roman" panose="02020603050405020304" pitchFamily="18" charset="0"/>
+                <a:cs typeface="Times New Roman" panose="02020603050405020304" pitchFamily="18" charset="0"/>
+              </a:rPr>
+              <a:t>print(</a:t>
+            </a:r>
+            <a:r>
+              <a:rPr sz="3000" dirty="0" err="1">
+                <a:solidFill>
+                  <a:schemeClr val="bg1"/>
+                </a:solidFill>
+                <a:latin typeface="Times New Roman" panose="02020603050405020304" pitchFamily="18" charset="0"/>
+                <a:cs typeface="Times New Roman" panose="02020603050405020304" pitchFamily="18" charset="0"/>
+              </a:rPr>
+              <a:t>email.find</a:t>
+            </a:r>
+            <a:r>
+              <a:rPr sz="3000" dirty="0">
+                <a:solidFill>
+                  <a:schemeClr val="bg1"/>
+                </a:solidFill>
+                <a:latin typeface="Times New Roman" panose="02020603050405020304" pitchFamily="18" charset="0"/>
+                <a:cs typeface="Times New Roman" panose="02020603050405020304" pitchFamily="18" charset="0"/>
+              </a:rPr>
+              <a:t>("@"))</a:t>
+            </a:r>
+          </a:p>
+          <a:p>
+            <a:endParaRPr sz="3000" dirty="0">
               <a:solidFill>
-                <a:srgbClr val="FFFFFF"/>
+                <a:schemeClr val="bg1"/>
               </a:solidFill>
-              <a:latin typeface="Times New Roman"/>
-              <a:ea typeface="Times New Roman"/>
-              <a:cs typeface="Times New Roman"/>
-              <a:sym typeface="Times New Roman"/>
+              <a:latin typeface="Times New Roman" panose="02020603050405020304" pitchFamily="18" charset="0"/>
+              <a:cs typeface="Times New Roman" panose="02020603050405020304" pitchFamily="18" charset="0"/>
             </a:endParaRPr>
           </a:p>
           <a:p>
-            <a:pPr algn="ctr">
-              <a:lnSpc>
-                <a:spcPts val="5039"/>
-              </a:lnSpc>
-            </a:pPr>
-            <a:r>
-              <a:rPr lang="en-US" sz="3599">
-                <a:solidFill>
-                  <a:srgbClr val="FFFFFF"/>
-                </a:solidFill>
-                <a:latin typeface="Times New Roman"/>
-                <a:ea typeface="Times New Roman"/>
-                <a:cs typeface="Times New Roman"/>
-                <a:sym typeface="Times New Roman"/>
-              </a:rPr>
-              <a:t>phone = "555-555-1234"</a:t>
-            </a:r>
-          </a:p>
-          <a:p>
-            <a:pPr algn="ctr">
-              <a:lnSpc>
-                <a:spcPts val="5039"/>
-              </a:lnSpc>
-            </a:pPr>
-            <a:r>
-              <a:rPr lang="en-US" sz="3599">
-                <a:solidFill>
-                  <a:srgbClr val="FFFFFF"/>
-                </a:solidFill>
-                <a:latin typeface="Times New Roman"/>
-                <a:ea typeface="Times New Roman"/>
-                <a:cs typeface="Times New Roman"/>
-                <a:sym typeface="Times New Roman"/>
-              </a:rPr>
-              <a:t>phone = phone.replace("-",  "")</a:t>
-            </a:r>
-          </a:p>
-          <a:p>
-            <a:pPr algn="ctr">
-              <a:lnSpc>
-                <a:spcPts val="5039"/>
-              </a:lnSpc>
-            </a:pPr>
-            <a:r>
-              <a:rPr lang="en-US" sz="3599">
-                <a:solidFill>
-                  <a:srgbClr val="FFFFFF"/>
-                </a:solidFill>
-                <a:latin typeface="Times New Roman"/>
-                <a:ea typeface="Times New Roman"/>
-                <a:cs typeface="Times New Roman"/>
-                <a:sym typeface="Times New Roman"/>
-              </a:rPr>
-              <a:t>print(phone)</a:t>
-            </a:r>
-          </a:p>
-          <a:p>
-            <a:pPr algn="ctr">
-              <a:lnSpc>
-                <a:spcPts val="5039"/>
-              </a:lnSpc>
-            </a:pPr>
-            <a:endParaRPr lang="en-US" sz="3599">
+            <a:r>
+              <a:rPr sz="3000" dirty="0" err="1">
+                <a:solidFill>
+                  <a:schemeClr val="bg1"/>
+                </a:solidFill>
+                <a:latin typeface="Times New Roman" panose="02020603050405020304" pitchFamily="18" charset="0"/>
+                <a:cs typeface="Times New Roman" panose="02020603050405020304" pitchFamily="18" charset="0"/>
+              </a:rPr>
+              <a:t>phone_number</a:t>
+            </a:r>
+            <a:r>
+              <a:rPr sz="3000" dirty="0">
+                <a:solidFill>
+                  <a:schemeClr val="bg1"/>
+                </a:solidFill>
+                <a:latin typeface="Times New Roman" panose="02020603050405020304" pitchFamily="18" charset="0"/>
+                <a:cs typeface="Times New Roman" panose="02020603050405020304" pitchFamily="18" charset="0"/>
+              </a:rPr>
+              <a:t> = "555-555-1234"</a:t>
+            </a:r>
+          </a:p>
+          <a:p>
+            <a:r>
+              <a:rPr sz="3000" dirty="0" err="1">
+                <a:solidFill>
+                  <a:schemeClr val="bg1"/>
+                </a:solidFill>
+                <a:latin typeface="Times New Roman" panose="02020603050405020304" pitchFamily="18" charset="0"/>
+                <a:cs typeface="Times New Roman" panose="02020603050405020304" pitchFamily="18" charset="0"/>
+              </a:rPr>
+              <a:t>phone_number</a:t>
+            </a:r>
+            <a:r>
+              <a:rPr sz="3000" dirty="0">
+                <a:solidFill>
+                  <a:schemeClr val="bg1"/>
+                </a:solidFill>
+                <a:latin typeface="Times New Roman" panose="02020603050405020304" pitchFamily="18" charset="0"/>
+                <a:cs typeface="Times New Roman" panose="02020603050405020304" pitchFamily="18" charset="0"/>
+              </a:rPr>
+              <a:t> = </a:t>
+            </a:r>
+            <a:r>
+              <a:rPr sz="3000" dirty="0" err="1">
+                <a:solidFill>
+                  <a:schemeClr val="bg1"/>
+                </a:solidFill>
+                <a:latin typeface="Times New Roman" panose="02020603050405020304" pitchFamily="18" charset="0"/>
+                <a:cs typeface="Times New Roman" panose="02020603050405020304" pitchFamily="18" charset="0"/>
+              </a:rPr>
+              <a:t>phone_number.replace</a:t>
+            </a:r>
+            <a:r>
+              <a:rPr sz="3000" dirty="0">
+                <a:solidFill>
+                  <a:schemeClr val="bg1"/>
+                </a:solidFill>
+                <a:latin typeface="Times New Roman" panose="02020603050405020304" pitchFamily="18" charset="0"/>
+                <a:cs typeface="Times New Roman" panose="02020603050405020304" pitchFamily="18" charset="0"/>
+              </a:rPr>
+              <a:t>("-", "")</a:t>
+            </a:r>
+          </a:p>
+          <a:p>
+            <a:r>
+              <a:rPr sz="3000" dirty="0">
+                <a:solidFill>
+                  <a:schemeClr val="bg1"/>
+                </a:solidFill>
+                <a:latin typeface="Times New Roman" panose="02020603050405020304" pitchFamily="18" charset="0"/>
+                <a:cs typeface="Times New Roman" panose="02020603050405020304" pitchFamily="18" charset="0"/>
+              </a:rPr>
+              <a:t>print(</a:t>
+            </a:r>
+            <a:r>
+              <a:rPr sz="3000" dirty="0" err="1">
+                <a:solidFill>
+                  <a:schemeClr val="bg1"/>
+                </a:solidFill>
+                <a:latin typeface="Times New Roman" panose="02020603050405020304" pitchFamily="18" charset="0"/>
+                <a:cs typeface="Times New Roman" panose="02020603050405020304" pitchFamily="18" charset="0"/>
+              </a:rPr>
+              <a:t>phone_number</a:t>
+            </a:r>
+            <a:r>
+              <a:rPr sz="3000" dirty="0">
+                <a:solidFill>
+                  <a:schemeClr val="bg1"/>
+                </a:solidFill>
+                <a:latin typeface="Times New Roman" panose="02020603050405020304" pitchFamily="18" charset="0"/>
+                <a:cs typeface="Times New Roman" panose="02020603050405020304" pitchFamily="18" charset="0"/>
+              </a:rPr>
+              <a:t>)</a:t>
+            </a:r>
+          </a:p>
+          <a:p>
+            <a:endParaRPr sz="3000" dirty="0">
               <a:solidFill>
-                <a:srgbClr val="FFFFFF"/>
+                <a:schemeClr val="bg1"/>
               </a:solidFill>
-              <a:latin typeface="Times New Roman"/>
-              <a:ea typeface="Times New Roman"/>
-              <a:cs typeface="Times New Roman"/>
-              <a:sym typeface="Times New Roman"/>
+              <a:latin typeface="Times New Roman" panose="02020603050405020304" pitchFamily="18" charset="0"/>
+              <a:cs typeface="Times New Roman" panose="02020603050405020304" pitchFamily="18" charset="0"/>
             </a:endParaRPr>
           </a:p>
           <a:p>
-            <a:pPr algn="ctr">
-              <a:lnSpc>
-                <a:spcPts val="5039"/>
-              </a:lnSpc>
-            </a:pPr>
-            <a:r>
-              <a:rPr lang="en-US" sz="3599">
-                <a:solidFill>
-                  <a:srgbClr val="FFFFFF"/>
-                </a:solidFill>
-                <a:latin typeface="Times New Roman"/>
-                <a:ea typeface="Times New Roman"/>
-                <a:cs typeface="Times New Roman"/>
-                <a:sym typeface="Times New Roman"/>
+            <a:r>
+              <a:rPr sz="3000" dirty="0">
+                <a:solidFill>
+                  <a:schemeClr val="bg1"/>
+                </a:solidFill>
+                <a:latin typeface="Times New Roman" panose="02020603050405020304" pitchFamily="18" charset="0"/>
+                <a:cs typeface="Times New Roman" panose="02020603050405020304" pitchFamily="18" charset="0"/>
               </a:rPr>
               <a:t>email = "joel@murach.com"</a:t>
             </a:r>
           </a:p>
           <a:p>
-            <a:pPr algn="ctr">
-              <a:lnSpc>
-                <a:spcPts val="5039"/>
-              </a:lnSpc>
-            </a:pPr>
-            <a:r>
-              <a:rPr lang="en-US" sz="3599">
-                <a:solidFill>
-                  <a:srgbClr val="FFFFFF"/>
-                </a:solidFill>
-                <a:latin typeface="Times New Roman"/>
-                <a:ea typeface="Times New Roman"/>
-                <a:cs typeface="Times New Roman"/>
-                <a:sym typeface="Times New Roman"/>
-              </a:rPr>
-              <a:t>print(email.removeprefix("joel"))</a:t>
+            <a:r>
+              <a:rPr sz="3000" dirty="0">
+                <a:solidFill>
+                  <a:schemeClr val="bg1"/>
+                </a:solidFill>
+                <a:latin typeface="Times New Roman" panose="02020603050405020304" pitchFamily="18" charset="0"/>
+                <a:cs typeface="Times New Roman" panose="02020603050405020304" pitchFamily="18" charset="0"/>
+              </a:rPr>
+              <a:t>print(</a:t>
+            </a:r>
+            <a:r>
+              <a:rPr sz="3000" dirty="0" err="1">
+                <a:solidFill>
+                  <a:schemeClr val="bg1"/>
+                </a:solidFill>
+                <a:latin typeface="Times New Roman" panose="02020603050405020304" pitchFamily="18" charset="0"/>
+                <a:cs typeface="Times New Roman" panose="02020603050405020304" pitchFamily="18" charset="0"/>
+              </a:rPr>
+              <a:t>email.removeprefix</a:t>
+            </a:r>
+            <a:r>
+              <a:rPr sz="3000" dirty="0">
+                <a:solidFill>
+                  <a:schemeClr val="bg1"/>
+                </a:solidFill>
+                <a:latin typeface="Times New Roman" panose="02020603050405020304" pitchFamily="18" charset="0"/>
+                <a:cs typeface="Times New Roman" panose="02020603050405020304" pitchFamily="18" charset="0"/>
+              </a:rPr>
+              <a:t>("</a:t>
+            </a:r>
+            <a:r>
+              <a:rPr sz="3000" dirty="0" err="1">
+                <a:solidFill>
+                  <a:schemeClr val="bg1"/>
+                </a:solidFill>
+                <a:latin typeface="Times New Roman" panose="02020603050405020304" pitchFamily="18" charset="0"/>
+                <a:cs typeface="Times New Roman" panose="02020603050405020304" pitchFamily="18" charset="0"/>
+              </a:rPr>
+              <a:t>joel</a:t>
+            </a:r>
+            <a:r>
+              <a:rPr sz="3000" dirty="0">
+                <a:solidFill>
+                  <a:schemeClr val="bg1"/>
+                </a:solidFill>
+                <a:latin typeface="Times New Roman" panose="02020603050405020304" pitchFamily="18" charset="0"/>
+                <a:cs typeface="Times New Roman" panose="02020603050405020304" pitchFamily="18" charset="0"/>
+              </a:rPr>
+              <a:t>"))</a:t>
             </a:r>
           </a:p>
         </p:txBody>
@@ -5181,7 +5637,7 @@
 </p:sld>
 </file>
 
-<file path=ppt/slides/slide6.xml><?xml version="1.0" encoding="utf-8"?>
+<file path=ppt/slides/slide7.xml><?xml version="1.0" encoding="utf-8"?>
 <p:sld xmlns:a="http://schemas.openxmlformats.org/drawingml/2006/main" xmlns:r="http://schemas.openxmlformats.org/officeDocument/2006/relationships" xmlns:p="http://schemas.openxmlformats.org/presentationml/2006/main">
   <p:cSld>
     <p:spTree>
@@ -5323,7 +5779,7 @@
         <p:spPr>
           <a:xfrm>
             <a:off x="771095" y="1577226"/>
-            <a:ext cx="5665389" cy="858377"/>
+            <a:ext cx="5665389" cy="615553"/>
           </a:xfrm>
           <a:prstGeom prst="rect">
             <a:avLst/>
@@ -5335,46 +5791,12 @@
           </a:bodyPr>
           <a:lstStyle/>
           <a:p>
-            <a:pPr marL="561339" lvl="1" algn="l">
-              <a:lnSpc>
-                <a:spcPts val="7279"/>
-              </a:lnSpc>
-            </a:pPr>
-            <a:r>
-              <a:rPr lang="en-US" altLang="zh-TW" sz="5199" b="1" dirty="0">
-                <a:solidFill>
-                  <a:srgbClr val="000B3D"/>
-                </a:solidFill>
-                <a:latin typeface="Times New Roman Bold"/>
-                <a:ea typeface="Times New Roman Bold"/>
-                <a:cs typeface="Times New Roman Bold"/>
-                <a:sym typeface="Times New Roman Bold"/>
-              </a:rPr>
-              <a:t>5.</a:t>
-            </a:r>
-            <a:r>
-              <a:rPr lang="zh-TW" altLang="en-US" sz="5199" b="1" dirty="0">
-                <a:solidFill>
-                  <a:srgbClr val="000B3D"/>
-                </a:solidFill>
-                <a:latin typeface="Times New Roman Bold"/>
-                <a:ea typeface="Times New Roman Bold"/>
-                <a:cs typeface="Times New Roman Bold"/>
-                <a:sym typeface="Times New Roman Bold"/>
-              </a:rPr>
-              <a:t> </a:t>
-            </a:r>
-            <a:r>
-              <a:rPr lang="en-US" sz="5199" b="1" dirty="0">
-                <a:solidFill>
-                  <a:srgbClr val="000B3D"/>
-                </a:solidFill>
-                <a:latin typeface="Times New Roman Bold"/>
-                <a:ea typeface="Times New Roman Bold"/>
-                <a:cs typeface="Times New Roman Bold"/>
-                <a:sym typeface="Times New Roman Bold"/>
-              </a:rPr>
-              <a:t>Split Strings</a:t>
+            <a:r>
+              <a:rPr sz="4000" dirty="0">
+                <a:latin typeface="Times New Roman" panose="02020603050405020304" pitchFamily="18" charset="0"/>
+                <a:cs typeface="Times New Roman" panose="02020603050405020304" pitchFamily="18" charset="0"/>
+              </a:rPr>
+              <a:t>6. Split Strings</a:t>
             </a:r>
           </a:p>
         </p:txBody>
@@ -5467,7 +5889,7 @@
         <p:spPr>
           <a:xfrm>
             <a:off x="9579744" y="2872740"/>
-            <a:ext cx="7284309" cy="6385560"/>
+            <a:ext cx="7284309" cy="5539978"/>
           </a:xfrm>
           <a:prstGeom prst="rect">
             <a:avLst/>
@@ -5479,187 +5901,197 @@
           </a:bodyPr>
           <a:lstStyle/>
           <a:p>
-            <a:pPr algn="ctr">
-              <a:lnSpc>
-                <a:spcPts val="5039"/>
-              </a:lnSpc>
-            </a:pPr>
-            <a:r>
-              <a:rPr lang="en-US" sz="3599">
-                <a:solidFill>
-                  <a:srgbClr val="FFFFFF"/>
-                </a:solidFill>
-                <a:latin typeface="Times New Roman"/>
-                <a:ea typeface="Times New Roman"/>
-                <a:cs typeface="Times New Roman"/>
-                <a:sym typeface="Times New Roman"/>
-              </a:rPr>
-              <a:t>quotation = "These are the times"</a:t>
-            </a:r>
-          </a:p>
-          <a:p>
-            <a:pPr algn="ctr">
-              <a:lnSpc>
-                <a:spcPts val="5039"/>
-              </a:lnSpc>
-            </a:pPr>
-            <a:r>
-              <a:rPr lang="en-US" sz="3599">
-                <a:solidFill>
-                  <a:srgbClr val="FFFFFF"/>
-                </a:solidFill>
-                <a:latin typeface="Times New Roman"/>
-                <a:ea typeface="Times New Roman"/>
-                <a:cs typeface="Times New Roman"/>
-                <a:sym typeface="Times New Roman"/>
-              </a:rPr>
-              <a:t>words = qoatation.split()</a:t>
-            </a:r>
-          </a:p>
-          <a:p>
-            <a:pPr algn="ctr">
-              <a:lnSpc>
-                <a:spcPts val="5039"/>
-              </a:lnSpc>
-            </a:pPr>
-            <a:r>
-              <a:rPr lang="en-US" sz="3599">
-                <a:solidFill>
-                  <a:srgbClr val="FFFFFF"/>
-                </a:solidFill>
-                <a:latin typeface="Times New Roman"/>
-                <a:ea typeface="Times New Roman"/>
-                <a:cs typeface="Times New Roman"/>
-                <a:sym typeface="Times New Roman"/>
-              </a:rPr>
-              <a:t>print(words)</a:t>
-            </a:r>
-          </a:p>
-          <a:p>
-            <a:pPr algn="ctr">
-              <a:lnSpc>
-                <a:spcPts val="5039"/>
-              </a:lnSpc>
-            </a:pPr>
-            <a:endParaRPr lang="en-US" sz="3599">
+            <a:r>
+              <a:rPr sz="3000" dirty="0">
+                <a:solidFill>
+                  <a:schemeClr val="bg1"/>
+                </a:solidFill>
+                <a:latin typeface="Times New Roman" panose="02020603050405020304" pitchFamily="18" charset="0"/>
+                <a:cs typeface="Times New Roman" panose="02020603050405020304" pitchFamily="18" charset="0"/>
+              </a:rPr>
+              <a:t>quotation = "These are the times that try men's souls."</a:t>
+            </a:r>
+          </a:p>
+          <a:p>
+            <a:r>
+              <a:rPr sz="3000" dirty="0">
+                <a:solidFill>
+                  <a:schemeClr val="bg1"/>
+                </a:solidFill>
+                <a:latin typeface="Times New Roman" panose="02020603050405020304" pitchFamily="18" charset="0"/>
+                <a:cs typeface="Times New Roman" panose="02020603050405020304" pitchFamily="18" charset="0"/>
+              </a:rPr>
+              <a:t>words = </a:t>
+            </a:r>
+            <a:r>
+              <a:rPr sz="3000" dirty="0" err="1">
+                <a:solidFill>
+                  <a:schemeClr val="bg1"/>
+                </a:solidFill>
+                <a:latin typeface="Times New Roman" panose="02020603050405020304" pitchFamily="18" charset="0"/>
+                <a:cs typeface="Times New Roman" panose="02020603050405020304" pitchFamily="18" charset="0"/>
+              </a:rPr>
+              <a:t>quotation.split</a:t>
+            </a:r>
+            <a:r>
+              <a:rPr sz="3000" dirty="0">
+                <a:solidFill>
+                  <a:schemeClr val="bg1"/>
+                </a:solidFill>
+                <a:latin typeface="Times New Roman" panose="02020603050405020304" pitchFamily="18" charset="0"/>
+                <a:cs typeface="Times New Roman" panose="02020603050405020304" pitchFamily="18" charset="0"/>
+              </a:rPr>
+              <a:t>()</a:t>
+            </a:r>
+          </a:p>
+          <a:p>
+            <a:r>
+              <a:rPr sz="3000" dirty="0">
+                <a:solidFill>
+                  <a:schemeClr val="bg1"/>
+                </a:solidFill>
+                <a:latin typeface="Times New Roman" panose="02020603050405020304" pitchFamily="18" charset="0"/>
+                <a:cs typeface="Times New Roman" panose="02020603050405020304" pitchFamily="18" charset="0"/>
+              </a:rPr>
+              <a:t>print(words[0])</a:t>
+            </a:r>
+          </a:p>
+          <a:p>
+            <a:endParaRPr sz="3000" dirty="0">
               <a:solidFill>
-                <a:srgbClr val="FFFFFF"/>
+                <a:schemeClr val="bg1"/>
               </a:solidFill>
-              <a:latin typeface="Times New Roman"/>
-              <a:ea typeface="Times New Roman"/>
-              <a:cs typeface="Times New Roman"/>
-              <a:sym typeface="Times New Roman"/>
+              <a:latin typeface="Times New Roman" panose="02020603050405020304" pitchFamily="18" charset="0"/>
+              <a:cs typeface="Times New Roman" panose="02020603050405020304" pitchFamily="18" charset="0"/>
             </a:endParaRPr>
           </a:p>
           <a:p>
-            <a:pPr algn="ctr">
-              <a:lnSpc>
-                <a:spcPts val="5039"/>
-              </a:lnSpc>
-            </a:pPr>
-            <a:r>
-              <a:rPr lang="en-US" sz="3599">
-                <a:solidFill>
-                  <a:srgbClr val="FFFFFF"/>
-                </a:solidFill>
-                <a:latin typeface="Times New Roman"/>
-                <a:ea typeface="Times New Roman"/>
-                <a:cs typeface="Times New Roman"/>
-                <a:sym typeface="Times New Roman"/>
+            <a:r>
+              <a:rPr sz="3000" dirty="0">
+                <a:solidFill>
+                  <a:schemeClr val="bg1"/>
+                </a:solidFill>
+                <a:latin typeface="Times New Roman" panose="02020603050405020304" pitchFamily="18" charset="0"/>
+                <a:cs typeface="Times New Roman" panose="02020603050405020304" pitchFamily="18" charset="0"/>
               </a:rPr>
               <a:t>date = "11/9/1972"</a:t>
             </a:r>
           </a:p>
           <a:p>
-            <a:pPr algn="ctr">
-              <a:lnSpc>
-                <a:spcPts val="5039"/>
-              </a:lnSpc>
-            </a:pPr>
-            <a:r>
-              <a:rPr lang="en-US" sz="3599">
-                <a:solidFill>
-                  <a:srgbClr val="FFFFFF"/>
-                </a:solidFill>
-                <a:latin typeface="Times New Roman"/>
-                <a:ea typeface="Times New Roman"/>
-                <a:cs typeface="Times New Roman"/>
-                <a:sym typeface="Times New Roman"/>
-              </a:rPr>
-              <a:t>date = date.split("/")</a:t>
-            </a:r>
-          </a:p>
-          <a:p>
-            <a:pPr algn="ctr">
-              <a:lnSpc>
-                <a:spcPts val="5039"/>
-              </a:lnSpc>
-            </a:pPr>
-            <a:r>
-              <a:rPr lang="en-US" sz="3599">
-                <a:solidFill>
-                  <a:srgbClr val="FFFFFF"/>
-                </a:solidFill>
-                <a:latin typeface="Times New Roman"/>
-                <a:ea typeface="Times New Roman"/>
-                <a:cs typeface="Times New Roman"/>
-                <a:sym typeface="Times New Roman"/>
+            <a:r>
+              <a:rPr sz="3000" dirty="0">
+                <a:solidFill>
+                  <a:schemeClr val="bg1"/>
+                </a:solidFill>
+                <a:latin typeface="Times New Roman" panose="02020603050405020304" pitchFamily="18" charset="0"/>
+                <a:cs typeface="Times New Roman" panose="02020603050405020304" pitchFamily="18" charset="0"/>
+              </a:rPr>
+              <a:t>date = </a:t>
+            </a:r>
+            <a:r>
+              <a:rPr sz="3000" dirty="0" err="1">
+                <a:solidFill>
+                  <a:schemeClr val="bg1"/>
+                </a:solidFill>
+                <a:latin typeface="Times New Roman" panose="02020603050405020304" pitchFamily="18" charset="0"/>
+                <a:cs typeface="Times New Roman" panose="02020603050405020304" pitchFamily="18" charset="0"/>
+              </a:rPr>
+              <a:t>date.split</a:t>
+            </a:r>
+            <a:r>
+              <a:rPr sz="3000" dirty="0">
+                <a:solidFill>
+                  <a:schemeClr val="bg1"/>
+                </a:solidFill>
+                <a:latin typeface="Times New Roman" panose="02020603050405020304" pitchFamily="18" charset="0"/>
+                <a:cs typeface="Times New Roman" panose="02020603050405020304" pitchFamily="18" charset="0"/>
+              </a:rPr>
+              <a:t>("/")</a:t>
+            </a:r>
+          </a:p>
+          <a:p>
+            <a:r>
+              <a:rPr sz="3000" dirty="0">
+                <a:solidFill>
+                  <a:schemeClr val="bg1"/>
+                </a:solidFill>
+                <a:latin typeface="Times New Roman" panose="02020603050405020304" pitchFamily="18" charset="0"/>
+                <a:cs typeface="Times New Roman" panose="02020603050405020304" pitchFamily="18" charset="0"/>
               </a:rPr>
               <a:t>print(date)</a:t>
             </a:r>
           </a:p>
           <a:p>
-            <a:pPr algn="ctr">
-              <a:lnSpc>
-                <a:spcPts val="5039"/>
-              </a:lnSpc>
-            </a:pPr>
-            <a:endParaRPr lang="en-US" sz="3599">
+            <a:endParaRPr sz="3000" dirty="0">
               <a:solidFill>
-                <a:srgbClr val="FFFFFF"/>
+                <a:schemeClr val="bg1"/>
               </a:solidFill>
-              <a:latin typeface="Times New Roman"/>
-              <a:ea typeface="Times New Roman"/>
-              <a:cs typeface="Times New Roman"/>
-              <a:sym typeface="Times New Roman"/>
+              <a:latin typeface="Times New Roman" panose="02020603050405020304" pitchFamily="18" charset="0"/>
+              <a:cs typeface="Times New Roman" panose="02020603050405020304" pitchFamily="18" charset="0"/>
             </a:endParaRPr>
           </a:p>
           <a:p>
-            <a:pPr algn="ctr">
-              <a:lnSpc>
-                <a:spcPts val="5039"/>
-              </a:lnSpc>
-            </a:pPr>
-            <a:r>
-              <a:rPr lang="en-US" sz="3599">
-                <a:solidFill>
-                  <a:srgbClr val="FFFFFF"/>
-                </a:solidFill>
-                <a:latin typeface="Times New Roman"/>
-                <a:ea typeface="Times New Roman"/>
-                <a:cs typeface="Times New Roman"/>
-                <a:sym typeface="Times New Roman"/>
-              </a:rPr>
-              <a:t>address = "John Doe|New York|NY"</a:t>
-            </a:r>
-          </a:p>
-          <a:p>
-            <a:pPr algn="ctr">
-              <a:lnSpc>
-                <a:spcPts val="5039"/>
-              </a:lnSpc>
-            </a:pPr>
-            <a:r>
-              <a:rPr lang="en-US" sz="3599">
-                <a:solidFill>
-                  <a:srgbClr val="FFFFFF"/>
-                </a:solidFill>
-                <a:latin typeface="Times New Roman"/>
-                <a:ea typeface="Times New Roman"/>
-                <a:cs typeface="Times New Roman"/>
-                <a:sym typeface="Times New Roman"/>
-              </a:rPr>
-              <a:t>print(address.split("|"))</a:t>
+            <a:r>
+              <a:rPr sz="3000" dirty="0">
+                <a:solidFill>
+                  <a:schemeClr val="bg1"/>
+                </a:solidFill>
+                <a:latin typeface="Times New Roman" panose="02020603050405020304" pitchFamily="18" charset="0"/>
+                <a:cs typeface="Times New Roman" panose="02020603050405020304" pitchFamily="18" charset="0"/>
+              </a:rPr>
+              <a:t>address = "John Doe|1500 Any </a:t>
+            </a:r>
+            <a:r>
+              <a:rPr sz="3000" dirty="0" err="1">
+                <a:solidFill>
+                  <a:schemeClr val="bg1"/>
+                </a:solidFill>
+                <a:latin typeface="Times New Roman" panose="02020603050405020304" pitchFamily="18" charset="0"/>
+                <a:cs typeface="Times New Roman" panose="02020603050405020304" pitchFamily="18" charset="0"/>
+              </a:rPr>
+              <a:t>Street|New</a:t>
+            </a:r>
+            <a:r>
+              <a:rPr sz="3000" dirty="0">
+                <a:solidFill>
+                  <a:schemeClr val="bg1"/>
+                </a:solidFill>
+                <a:latin typeface="Times New Roman" panose="02020603050405020304" pitchFamily="18" charset="0"/>
+                <a:cs typeface="Times New Roman" panose="02020603050405020304" pitchFamily="18" charset="0"/>
+              </a:rPr>
+              <a:t> York|NY|10001"</a:t>
+            </a:r>
+          </a:p>
+          <a:p>
+            <a:r>
+              <a:rPr sz="3000" dirty="0">
+                <a:solidFill>
+                  <a:schemeClr val="bg1"/>
+                </a:solidFill>
+                <a:latin typeface="Times New Roman" panose="02020603050405020304" pitchFamily="18" charset="0"/>
+                <a:cs typeface="Times New Roman" panose="02020603050405020304" pitchFamily="18" charset="0"/>
+              </a:rPr>
+              <a:t>print(</a:t>
+            </a:r>
+            <a:r>
+              <a:rPr sz="3000" dirty="0" err="1">
+                <a:solidFill>
+                  <a:schemeClr val="bg1"/>
+                </a:solidFill>
+                <a:latin typeface="Times New Roman" panose="02020603050405020304" pitchFamily="18" charset="0"/>
+                <a:cs typeface="Times New Roman" panose="02020603050405020304" pitchFamily="18" charset="0"/>
+              </a:rPr>
+              <a:t>address.split</a:t>
+            </a:r>
+            <a:r>
+              <a:rPr sz="3000" dirty="0">
+                <a:solidFill>
+                  <a:schemeClr val="bg1"/>
+                </a:solidFill>
+                <a:latin typeface="Times New Roman" panose="02020603050405020304" pitchFamily="18" charset="0"/>
+                <a:cs typeface="Times New Roman" panose="02020603050405020304" pitchFamily="18" charset="0"/>
+              </a:rPr>
+              <a:t>("|"))</a:t>
             </a:r>
           </a:p>
         </p:txBody>
@@ -5672,7 +6104,7 @@
 </p:sld>
 </file>
 
-<file path=ppt/slides/slide7.xml><?xml version="1.0" encoding="utf-8"?>
+<file path=ppt/slides/slide8.xml><?xml version="1.0" encoding="utf-8"?>
 <p:sld xmlns:a="http://schemas.openxmlformats.org/drawingml/2006/main" xmlns:r="http://schemas.openxmlformats.org/officeDocument/2006/relationships" xmlns:p="http://schemas.openxmlformats.org/presentationml/2006/main">
   <p:cSld>
     <p:spTree>
@@ -5814,7 +6246,7 @@
         <p:spPr>
           <a:xfrm>
             <a:off x="811610" y="1344809"/>
-            <a:ext cx="5360589" cy="858377"/>
+            <a:ext cx="5360589" cy="615553"/>
           </a:xfrm>
           <a:prstGeom prst="rect">
             <a:avLst/>
@@ -5826,46 +6258,12 @@
           </a:bodyPr>
           <a:lstStyle/>
           <a:p>
-            <a:pPr marL="561339" lvl="1" algn="l">
-              <a:lnSpc>
-                <a:spcPts val="7279"/>
-              </a:lnSpc>
-            </a:pPr>
-            <a:r>
-              <a:rPr lang="en-US" altLang="zh-TW" sz="5199" b="1" dirty="0">
-                <a:solidFill>
-                  <a:srgbClr val="000B3D"/>
-                </a:solidFill>
-                <a:latin typeface="Times New Roman Bold"/>
-                <a:ea typeface="Times New Roman Bold"/>
-                <a:cs typeface="Times New Roman Bold"/>
-                <a:sym typeface="Times New Roman Bold"/>
-              </a:rPr>
-              <a:t>6.</a:t>
-            </a:r>
-            <a:r>
-              <a:rPr lang="zh-TW" altLang="en-US" sz="5199" b="1" dirty="0">
-                <a:solidFill>
-                  <a:srgbClr val="000B3D"/>
-                </a:solidFill>
-                <a:latin typeface="Times New Roman Bold"/>
-                <a:ea typeface="Times New Roman Bold"/>
-                <a:cs typeface="Times New Roman Bold"/>
-                <a:sym typeface="Times New Roman Bold"/>
-              </a:rPr>
-              <a:t> </a:t>
-            </a:r>
-            <a:r>
-              <a:rPr lang="en-US" sz="5199" b="1" dirty="0">
-                <a:solidFill>
-                  <a:srgbClr val="000B3D"/>
-                </a:solidFill>
-                <a:latin typeface="Times New Roman Bold"/>
-                <a:ea typeface="Times New Roman Bold"/>
-                <a:cs typeface="Times New Roman Bold"/>
-                <a:sym typeface="Times New Roman Bold"/>
-              </a:rPr>
-              <a:t>Join Strings</a:t>
+            <a:r>
+              <a:rPr sz="4000" dirty="0">
+                <a:latin typeface="Times New Roman" panose="02020603050405020304" pitchFamily="18" charset="0"/>
+                <a:cs typeface="Times New Roman" panose="02020603050405020304" pitchFamily="18" charset="0"/>
+              </a:rPr>
+              <a:t>7. Join Strings</a:t>
             </a:r>
           </a:p>
         </p:txBody>
@@ -5879,7 +6277,7 @@
         <p:spPr>
           <a:xfrm>
             <a:off x="953647" y="3633458"/>
-            <a:ext cx="7629779" cy="4222750"/>
+            <a:ext cx="7629779" cy="2154436"/>
           </a:xfrm>
           <a:prstGeom prst="rect">
             <a:avLst/>
@@ -5891,60 +6289,30 @@
           </a:bodyPr>
           <a:lstStyle/>
           <a:p>
-            <a:pPr algn="l">
-              <a:lnSpc>
-                <a:spcPts val="5599"/>
-              </a:lnSpc>
-            </a:pPr>
-            <a:r>
-              <a:rPr lang="en-US" sz="3999">
-                <a:solidFill>
-                  <a:srgbClr val="000B3D"/>
-                </a:solidFill>
-                <a:latin typeface="Times New Roman"/>
-                <a:ea typeface="Times New Roman"/>
-                <a:cs typeface="Times New Roman"/>
-                <a:sym typeface="Times New Roman"/>
+            <a:r>
+              <a:rPr sz="3500" dirty="0">
+                <a:latin typeface="Times New Roman" panose="02020603050405020304" pitchFamily="18" charset="0"/>
+                <a:cs typeface="Times New Roman" panose="02020603050405020304" pitchFamily="18" charset="0"/>
               </a:rPr>
               <a:t>join() combines a sequence into one string.</a:t>
             </a:r>
           </a:p>
           <a:p>
-            <a:pPr algn="l">
-              <a:lnSpc>
-                <a:spcPts val="5599"/>
-              </a:lnSpc>
-            </a:pPr>
-            <a:r>
-              <a:rPr lang="en-US" sz="3999">
-                <a:solidFill>
-                  <a:srgbClr val="000B3D"/>
-                </a:solidFill>
-                <a:latin typeface="Times New Roman"/>
-                <a:ea typeface="Times New Roman"/>
-                <a:cs typeface="Times New Roman"/>
-                <a:sym typeface="Times New Roman"/>
+            <a:r>
+              <a:rPr sz="3500" dirty="0">
+                <a:latin typeface="Times New Roman" panose="02020603050405020304" pitchFamily="18" charset="0"/>
+                <a:cs typeface="Times New Roman" panose="02020603050405020304" pitchFamily="18" charset="0"/>
               </a:rPr>
               <a:t>The delimiter is placed between each item.</a:t>
             </a:r>
           </a:p>
           <a:p>
-            <a:pPr algn="l">
-              <a:lnSpc>
-                <a:spcPts val="5599"/>
-              </a:lnSpc>
-            </a:pPr>
-            <a:r>
-              <a:rPr lang="en-US" sz="3999">
-                <a:solidFill>
-                  <a:srgbClr val="000B3D"/>
-                </a:solidFill>
-                <a:latin typeface="Times New Roman"/>
-                <a:ea typeface="Times New Roman"/>
-                <a:cs typeface="Times New Roman"/>
-                <a:sym typeface="Times New Roman"/>
-              </a:rPr>
-              <a:t>It is useful when working with list and text files.</a:t>
+            <a:r>
+              <a:rPr sz="3500" dirty="0">
+                <a:latin typeface="Times New Roman" panose="02020603050405020304" pitchFamily="18" charset="0"/>
+                <a:cs typeface="Times New Roman" panose="02020603050405020304" pitchFamily="18" charset="0"/>
+              </a:rPr>
+              <a:t>It is the opposite idea of split().</a:t>
             </a:r>
           </a:p>
         </p:txBody>
@@ -5958,7 +6326,7 @@
         <p:spPr>
           <a:xfrm>
             <a:off x="9579744" y="2245459"/>
-            <a:ext cx="7284309" cy="7023735"/>
+            <a:ext cx="7284309" cy="5539978"/>
           </a:xfrm>
           <a:prstGeom prst="rect">
             <a:avLst/>
@@ -5970,204 +6338,139 @@
           </a:bodyPr>
           <a:lstStyle/>
           <a:p>
-            <a:pPr algn="ctr">
-              <a:lnSpc>
-                <a:spcPts val="5039"/>
-              </a:lnSpc>
-            </a:pPr>
-            <a:r>
-              <a:rPr lang="en-US" sz="3599">
-                <a:solidFill>
-                  <a:srgbClr val="FFFFFF"/>
-                </a:solidFill>
-                <a:latin typeface="Times New Roman"/>
-                <a:ea typeface="Times New Roman"/>
-                <a:cs typeface="Times New Roman"/>
-                <a:sym typeface="Times New Roman"/>
+            <a:r>
+              <a:rPr sz="3000" dirty="0">
+                <a:solidFill>
+                  <a:schemeClr val="bg1"/>
+                </a:solidFill>
+                <a:latin typeface="Times New Roman" panose="02020603050405020304" pitchFamily="18" charset="0"/>
+                <a:cs typeface="Times New Roman" panose="02020603050405020304" pitchFamily="18" charset="0"/>
               </a:rPr>
               <a:t>address = [</a:t>
             </a:r>
           </a:p>
           <a:p>
-            <a:pPr algn="ctr">
-              <a:lnSpc>
-                <a:spcPts val="5039"/>
-              </a:lnSpc>
-            </a:pPr>
-            <a:r>
-              <a:rPr lang="en-US" sz="3599">
-                <a:solidFill>
-                  <a:srgbClr val="FFFFFF"/>
-                </a:solidFill>
-                <a:latin typeface="Times New Roman"/>
-                <a:ea typeface="Times New Roman"/>
-                <a:cs typeface="Times New Roman"/>
-                <a:sym typeface="Times New Roman"/>
-              </a:rPr>
-              <a:t>"John Doe",</a:t>
-            </a:r>
-          </a:p>
-          <a:p>
-            <a:pPr algn="ctr">
-              <a:lnSpc>
-                <a:spcPts val="5039"/>
-              </a:lnSpc>
-            </a:pPr>
-            <a:r>
-              <a:rPr lang="en-US" sz="3599">
-                <a:solidFill>
-                  <a:srgbClr val="FFFFFF"/>
-                </a:solidFill>
-                <a:latin typeface="Times New Roman"/>
-                <a:ea typeface="Times New Roman"/>
-                <a:cs typeface="Times New Roman"/>
-                <a:sym typeface="Times New Roman"/>
-              </a:rPr>
-              <a:t>"New York",</a:t>
-            </a:r>
-          </a:p>
-          <a:p>
-            <a:pPr algn="ctr">
-              <a:lnSpc>
-                <a:spcPts val="5039"/>
-              </a:lnSpc>
-            </a:pPr>
-            <a:r>
-              <a:rPr lang="en-US" sz="3599">
-                <a:solidFill>
-                  <a:srgbClr val="FFFFFF"/>
-                </a:solidFill>
-                <a:latin typeface="Times New Roman"/>
-                <a:ea typeface="Times New Roman"/>
-                <a:cs typeface="Times New Roman"/>
-                <a:sym typeface="Times New Roman"/>
-              </a:rPr>
-              <a:t>"NY",</a:t>
-            </a:r>
-          </a:p>
-          <a:p>
-            <a:pPr algn="ctr">
-              <a:lnSpc>
-                <a:spcPts val="5039"/>
-              </a:lnSpc>
-            </a:pPr>
-            <a:r>
-              <a:rPr lang="en-US" sz="3599">
-                <a:solidFill>
-                  <a:srgbClr val="FFFFFF"/>
-                </a:solidFill>
-                <a:latin typeface="Times New Roman"/>
-                <a:ea typeface="Times New Roman"/>
-                <a:cs typeface="Times New Roman"/>
-                <a:sym typeface="Times New Roman"/>
-              </a:rPr>
-              <a:t>"10001"</a:t>
-            </a:r>
-          </a:p>
-          <a:p>
-            <a:pPr algn="ctr">
-              <a:lnSpc>
-                <a:spcPts val="5039"/>
-              </a:lnSpc>
-            </a:pPr>
-            <a:r>
-              <a:rPr lang="en-US" sz="3599">
-                <a:solidFill>
-                  <a:srgbClr val="FFFFFF"/>
-                </a:solidFill>
-                <a:latin typeface="Times New Roman"/>
-                <a:ea typeface="Times New Roman"/>
-                <a:cs typeface="Times New Roman"/>
-                <a:sym typeface="Times New Roman"/>
+            <a:r>
+              <a:rPr sz="3000" dirty="0">
+                <a:solidFill>
+                  <a:schemeClr val="bg1"/>
+                </a:solidFill>
+                <a:latin typeface="Times New Roman" panose="02020603050405020304" pitchFamily="18" charset="0"/>
+                <a:cs typeface="Times New Roman" panose="02020603050405020304" pitchFamily="18" charset="0"/>
+              </a:rPr>
+              <a:t>    "John Doe",</a:t>
+            </a:r>
+          </a:p>
+          <a:p>
+            <a:r>
+              <a:rPr sz="3000" dirty="0">
+                <a:solidFill>
+                  <a:schemeClr val="bg1"/>
+                </a:solidFill>
+                <a:latin typeface="Times New Roman" panose="02020603050405020304" pitchFamily="18" charset="0"/>
+                <a:cs typeface="Times New Roman" panose="02020603050405020304" pitchFamily="18" charset="0"/>
+              </a:rPr>
+              <a:t>    "1500 Any Street",</a:t>
+            </a:r>
+          </a:p>
+          <a:p>
+            <a:r>
+              <a:rPr sz="3000" dirty="0">
+                <a:solidFill>
+                  <a:schemeClr val="bg1"/>
+                </a:solidFill>
+                <a:latin typeface="Times New Roman" panose="02020603050405020304" pitchFamily="18" charset="0"/>
+                <a:cs typeface="Times New Roman" panose="02020603050405020304" pitchFamily="18" charset="0"/>
+              </a:rPr>
+              <a:t>    "New York",</a:t>
+            </a:r>
+          </a:p>
+          <a:p>
+            <a:r>
+              <a:rPr sz="3000" dirty="0">
+                <a:solidFill>
+                  <a:schemeClr val="bg1"/>
+                </a:solidFill>
+                <a:latin typeface="Times New Roman" panose="02020603050405020304" pitchFamily="18" charset="0"/>
+                <a:cs typeface="Times New Roman" panose="02020603050405020304" pitchFamily="18" charset="0"/>
+              </a:rPr>
+              <a:t>    "NY",</a:t>
+            </a:r>
+          </a:p>
+          <a:p>
+            <a:r>
+              <a:rPr sz="3000" dirty="0">
+                <a:solidFill>
+                  <a:schemeClr val="bg1"/>
+                </a:solidFill>
+                <a:latin typeface="Times New Roman" panose="02020603050405020304" pitchFamily="18" charset="0"/>
+                <a:cs typeface="Times New Roman" panose="02020603050405020304" pitchFamily="18" charset="0"/>
+              </a:rPr>
+              <a:t>    "10001"</a:t>
+            </a:r>
+          </a:p>
+          <a:p>
+            <a:r>
+              <a:rPr sz="3000" dirty="0">
+                <a:solidFill>
+                  <a:schemeClr val="bg1"/>
+                </a:solidFill>
+                <a:latin typeface="Times New Roman" panose="02020603050405020304" pitchFamily="18" charset="0"/>
+                <a:cs typeface="Times New Roman" panose="02020603050405020304" pitchFamily="18" charset="0"/>
               </a:rPr>
               <a:t>]</a:t>
             </a:r>
           </a:p>
           <a:p>
-            <a:pPr algn="ctr">
-              <a:lnSpc>
-                <a:spcPts val="5039"/>
-              </a:lnSpc>
-            </a:pPr>
-            <a:endParaRPr lang="en-US" sz="3599">
+            <a:endParaRPr sz="3000" dirty="0">
               <a:solidFill>
-                <a:srgbClr val="FFFFFF"/>
+                <a:schemeClr val="bg1"/>
               </a:solidFill>
-              <a:latin typeface="Times New Roman"/>
-              <a:ea typeface="Times New Roman"/>
-              <a:cs typeface="Times New Roman"/>
-              <a:sym typeface="Times New Roman"/>
+              <a:latin typeface="Times New Roman" panose="02020603050405020304" pitchFamily="18" charset="0"/>
+              <a:cs typeface="Times New Roman" panose="02020603050405020304" pitchFamily="18" charset="0"/>
             </a:endParaRPr>
           </a:p>
           <a:p>
-            <a:pPr algn="ctr">
-              <a:lnSpc>
-                <a:spcPts val="5039"/>
-              </a:lnSpc>
-            </a:pPr>
-            <a:r>
-              <a:rPr lang="en-US" sz="3599">
-                <a:solidFill>
-                  <a:srgbClr val="FFFFFF"/>
-                </a:solidFill>
-                <a:latin typeface="Times New Roman"/>
-                <a:ea typeface="Times New Roman"/>
-                <a:cs typeface="Times New Roman"/>
-                <a:sym typeface="Times New Roman"/>
+            <a:r>
+              <a:rPr sz="3000" dirty="0">
+                <a:solidFill>
+                  <a:schemeClr val="bg1"/>
+                </a:solidFill>
+                <a:latin typeface="Times New Roman" panose="02020603050405020304" pitchFamily="18" charset="0"/>
+                <a:cs typeface="Times New Roman" panose="02020603050405020304" pitchFamily="18" charset="0"/>
               </a:rPr>
               <a:t>print("|".join(address))</a:t>
             </a:r>
           </a:p>
           <a:p>
-            <a:pPr algn="ctr">
-              <a:lnSpc>
-                <a:spcPts val="5039"/>
-              </a:lnSpc>
-            </a:pPr>
-            <a:endParaRPr lang="en-US" sz="3599">
+            <a:endParaRPr sz="3000" dirty="0">
               <a:solidFill>
-                <a:srgbClr val="FFFFFF"/>
+                <a:schemeClr val="bg1"/>
               </a:solidFill>
-              <a:latin typeface="Times New Roman"/>
-              <a:ea typeface="Times New Roman"/>
-              <a:cs typeface="Times New Roman"/>
-              <a:sym typeface="Times New Roman"/>
+              <a:latin typeface="Times New Roman" panose="02020603050405020304" pitchFamily="18" charset="0"/>
+              <a:cs typeface="Times New Roman" panose="02020603050405020304" pitchFamily="18" charset="0"/>
             </a:endParaRPr>
           </a:p>
           <a:p>
-            <a:pPr algn="ctr">
-              <a:lnSpc>
-                <a:spcPts val="5039"/>
-              </a:lnSpc>
-            </a:pPr>
-            <a:r>
-              <a:rPr lang="en-US" sz="3599">
-                <a:solidFill>
-                  <a:srgbClr val="FFFFFF"/>
-                </a:solidFill>
-                <a:latin typeface="Times New Roman"/>
-                <a:ea typeface="Times New Roman"/>
-                <a:cs typeface="Times New Roman"/>
-                <a:sym typeface="Times New Roman"/>
+            <a:r>
+              <a:rPr sz="3000" dirty="0">
+                <a:solidFill>
+                  <a:schemeClr val="bg1"/>
+                </a:solidFill>
+                <a:latin typeface="Times New Roman" panose="02020603050405020304" pitchFamily="18" charset="0"/>
+                <a:cs typeface="Times New Roman" panose="02020603050405020304" pitchFamily="18" charset="0"/>
               </a:rPr>
               <a:t>letters = "HORSE"</a:t>
             </a:r>
           </a:p>
           <a:p>
-            <a:pPr algn="ctr">
-              <a:lnSpc>
-                <a:spcPts val="5039"/>
-              </a:lnSpc>
-            </a:pPr>
-            <a:r>
-              <a:rPr lang="en-US" sz="3599">
-                <a:solidFill>
-                  <a:srgbClr val="FFFFFF"/>
-                </a:solidFill>
-                <a:latin typeface="Times New Roman"/>
-                <a:ea typeface="Times New Roman"/>
-                <a:cs typeface="Times New Roman"/>
-                <a:sym typeface="Times New Roman"/>
+            <a:r>
+              <a:rPr sz="3000" dirty="0">
+                <a:solidFill>
+                  <a:schemeClr val="bg1"/>
+                </a:solidFill>
+                <a:latin typeface="Times New Roman" panose="02020603050405020304" pitchFamily="18" charset="0"/>
+                <a:cs typeface="Times New Roman" panose="02020603050405020304" pitchFamily="18" charset="0"/>
               </a:rPr>
               <a:t>print(" ".join(letters))</a:t>
             </a:r>
@@ -6182,7 +6485,7 @@
 </p:sld>
 </file>
 
-<file path=ppt/slides/slide8.xml><?xml version="1.0" encoding="utf-8"?>
+<file path=ppt/slides/slide9.xml><?xml version="1.0" encoding="utf-8"?>
 <p:sld xmlns:a="http://schemas.openxmlformats.org/drawingml/2006/main" xmlns:r="http://schemas.openxmlformats.org/officeDocument/2006/relationships" xmlns:p="http://schemas.openxmlformats.org/presentationml/2006/main">
   <p:cSld>
     <p:spTree>
@@ -6199,57 +6502,178 @@
           <a:chExt cx="0" cy="0"/>
         </a:xfrm>
       </p:grpSpPr>
-      <p:sp>
-        <p:nvSpPr>
-          <p:cNvPr id="2" name="TextBox 2"/>
+      <p:grpSp>
+        <p:nvGrpSpPr>
+          <p:cNvPr id="2" name="Group 2"/>
+          <p:cNvGrpSpPr/>
+          <p:nvPr/>
+        </p:nvGrpSpPr>
+        <p:grpSpPr>
+          <a:xfrm>
+            <a:off x="9652408" y="2835888"/>
+            <a:ext cx="7439194" cy="5838056"/>
+            <a:chOff x="0" y="0"/>
+            <a:chExt cx="1959294" cy="1537595"/>
+          </a:xfrm>
+        </p:grpSpPr>
+        <p:sp>
+          <p:nvSpPr>
+            <p:cNvPr id="3" name="Freeform 3"/>
+            <p:cNvSpPr/>
+            <p:nvPr/>
+          </p:nvSpPr>
+          <p:spPr>
+            <a:xfrm>
+              <a:off x="0" y="0"/>
+              <a:ext cx="1959294" cy="1537595"/>
+            </a:xfrm>
+            <a:custGeom>
+              <a:avLst/>
+              <a:gdLst/>
+              <a:ahLst/>
+              <a:cxnLst/>
+              <a:rect l="l" t="t" r="r" b="b"/>
+              <a:pathLst>
+                <a:path w="1959294" h="1537595">
+                  <a:moveTo>
+                    <a:pt x="53075" y="0"/>
+                  </a:moveTo>
+                  <a:lnTo>
+                    <a:pt x="1906219" y="0"/>
+                  </a:lnTo>
+                  <a:cubicBezTo>
+                    <a:pt x="1920295" y="0"/>
+                    <a:pt x="1933795" y="5592"/>
+                    <a:pt x="1943749" y="15545"/>
+                  </a:cubicBezTo>
+                  <a:cubicBezTo>
+                    <a:pt x="1953702" y="25499"/>
+                    <a:pt x="1959294" y="38999"/>
+                    <a:pt x="1959294" y="53075"/>
+                  </a:cubicBezTo>
+                  <a:lnTo>
+                    <a:pt x="1959294" y="1484520"/>
+                  </a:lnTo>
+                  <a:cubicBezTo>
+                    <a:pt x="1959294" y="1498596"/>
+                    <a:pt x="1953702" y="1512096"/>
+                    <a:pt x="1943749" y="1522050"/>
+                  </a:cubicBezTo>
+                  <a:cubicBezTo>
+                    <a:pt x="1933795" y="1532003"/>
+                    <a:pt x="1920295" y="1537595"/>
+                    <a:pt x="1906219" y="1537595"/>
+                  </a:cubicBezTo>
+                  <a:lnTo>
+                    <a:pt x="53075" y="1537595"/>
+                  </a:lnTo>
+                  <a:cubicBezTo>
+                    <a:pt x="23763" y="1537595"/>
+                    <a:pt x="0" y="1513833"/>
+                    <a:pt x="0" y="1484520"/>
+                  </a:cubicBezTo>
+                  <a:lnTo>
+                    <a:pt x="0" y="53075"/>
+                  </a:lnTo>
+                  <a:cubicBezTo>
+                    <a:pt x="0" y="38999"/>
+                    <a:pt x="5592" y="25499"/>
+                    <a:pt x="15545" y="15545"/>
+                  </a:cubicBezTo>
+                  <a:cubicBezTo>
+                    <a:pt x="25499" y="5592"/>
+                    <a:pt x="38999" y="0"/>
+                    <a:pt x="53075" y="0"/>
+                  </a:cubicBezTo>
+                  <a:close/>
+                </a:path>
+              </a:pathLst>
+            </a:custGeom>
+            <a:solidFill>
+              <a:srgbClr val="000B3D"/>
+            </a:solidFill>
+          </p:spPr>
+          <p:txBody>
+            <a:bodyPr/>
+            <a:lstStyle/>
+            <a:p>
+              <a:endParaRPr lang="zh-TW" altLang="en-US"/>
+            </a:p>
+          </p:txBody>
+        </p:sp>
+        <p:sp>
+          <p:nvSpPr>
+            <p:cNvPr id="4" name="TextBox 4"/>
+            <p:cNvSpPr txBox="1"/>
+            <p:nvPr/>
+          </p:nvSpPr>
+          <p:spPr>
+            <a:xfrm>
+              <a:off x="0" y="-57150"/>
+              <a:ext cx="1959294" cy="1594745"/>
+            </a:xfrm>
+            <a:prstGeom prst="rect">
+              <a:avLst/>
+            </a:prstGeom>
+          </p:spPr>
+          <p:txBody>
+            <a:bodyPr lIns="50800" tIns="50800" rIns="50800" bIns="50800" rtlCol="0" anchor="ctr"/>
+            <a:lstStyle/>
+            <a:p>
+              <a:pPr algn="ctr">
+                <a:lnSpc>
+                  <a:spcPts val="2659"/>
+                </a:lnSpc>
+                <a:spcBef>
+                  <a:spcPct val="0"/>
+                </a:spcBef>
+              </a:pPr>
+              <a:endParaRPr/>
+            </a:p>
+          </p:txBody>
+        </p:sp>
+      </p:grpSp>
+      <p:sp>
+        <p:nvSpPr>
+          <p:cNvPr id="5" name="TextBox 5"/>
           <p:cNvSpPr txBox="1"/>
           <p:nvPr/>
         </p:nvSpPr>
         <p:spPr>
           <a:xfrm>
-            <a:off x="2780315" y="1427444"/>
-            <a:ext cx="3270647" cy="1064261"/>
+            <a:off x="836628" y="1920218"/>
+            <a:ext cx="9069371" cy="615553"/>
           </a:xfrm>
           <a:prstGeom prst="rect">
             <a:avLst/>
           </a:prstGeom>
         </p:spPr>
         <p:txBody>
-          <a:bodyPr lIns="0" tIns="0" rIns="0" bIns="0" rtlCol="0" anchor="t">
+          <a:bodyPr wrap="square" lIns="0" tIns="0" rIns="0" bIns="0" rtlCol="0" anchor="t">
             <a:spAutoFit/>
           </a:bodyPr>
           <a:lstStyle/>
           <a:p>
-            <a:pPr algn="ctr">
-              <a:lnSpc>
-                <a:spcPts val="8539"/>
-              </a:lnSpc>
-            </a:pPr>
-            <a:r>
-              <a:rPr lang="en-US" sz="6099" b="1">
-                <a:solidFill>
-                  <a:srgbClr val="000B3D"/>
-                </a:solidFill>
-                <a:latin typeface="Times New Roman Bold"/>
-                <a:ea typeface="Times New Roman Bold"/>
-                <a:cs typeface="Times New Roman Bold"/>
-                <a:sym typeface="Times New Roman Bold"/>
-              </a:rPr>
-              <a:t>Summary</a:t>
-            </a:r>
-          </a:p>
-        </p:txBody>
-      </p:sp>
-      <p:sp>
-        <p:nvSpPr>
-          <p:cNvPr id="3" name="TextBox 3"/>
+            <a:r>
+              <a:rPr sz="4000" dirty="0">
+                <a:latin typeface="Times New Roman" panose="02020603050405020304" pitchFamily="18" charset="0"/>
+                <a:cs typeface="Times New Roman" panose="02020603050405020304" pitchFamily="18" charset="0"/>
+              </a:rPr>
+              <a:t>8. Practice</a:t>
+            </a:r>
+          </a:p>
+        </p:txBody>
+      </p:sp>
+      <p:sp>
+        <p:nvSpPr>
+          <p:cNvPr id="6" name="TextBox 6"/>
           <p:cNvSpPr txBox="1"/>
           <p:nvPr/>
         </p:nvSpPr>
         <p:spPr>
           <a:xfrm>
-            <a:off x="2860732" y="3683403"/>
-            <a:ext cx="12558283" cy="3898266"/>
+            <a:off x="1412038" y="3891456"/>
+            <a:ext cx="7704832" cy="2154436"/>
           </a:xfrm>
           <a:prstGeom prst="rect">
             <a:avLst/>
@@ -6261,98 +6685,145 @@
           </a:bodyPr>
           <a:lstStyle/>
           <a:p>
-            <a:pPr algn="l">
-              <a:lnSpc>
-                <a:spcPts val="6159"/>
-              </a:lnSpc>
-            </a:pPr>
-            <a:r>
-              <a:rPr lang="en-US" sz="4399">
-                <a:solidFill>
-                  <a:srgbClr val="000B3D"/>
-                </a:solidFill>
-                <a:latin typeface="Times New Roman"/>
-                <a:ea typeface="Times New Roman"/>
-                <a:cs typeface="Times New Roman"/>
-                <a:sym typeface="Times New Roman"/>
-              </a:rPr>
-              <a:t>Use indexes and slicing to access string data.</a:t>
-            </a:r>
-          </a:p>
-          <a:p>
-            <a:pPr algn="l">
-              <a:lnSpc>
-                <a:spcPts val="6159"/>
-              </a:lnSpc>
-            </a:pPr>
-            <a:r>
-              <a:rPr lang="en-US" sz="4399">
-                <a:solidFill>
-                  <a:srgbClr val="000B3D"/>
-                </a:solidFill>
-                <a:latin typeface="Times New Roman"/>
-                <a:ea typeface="Times New Roman"/>
-                <a:cs typeface="Times New Roman"/>
-                <a:sym typeface="Times New Roman"/>
-              </a:rPr>
-              <a:t>Use in and for to search and process strings.</a:t>
-            </a:r>
-          </a:p>
-          <a:p>
-            <a:pPr algn="l">
-              <a:lnSpc>
-                <a:spcPts val="6159"/>
-              </a:lnSpc>
-            </a:pPr>
-            <a:r>
-              <a:rPr lang="en-US" sz="4399">
-                <a:solidFill>
-                  <a:srgbClr val="000B3D"/>
-                </a:solidFill>
-                <a:latin typeface="Times New Roman"/>
-                <a:ea typeface="Times New Roman"/>
-                <a:cs typeface="Times New Roman"/>
-                <a:sym typeface="Times New Roman"/>
-              </a:rPr>
-              <a:t>Use string methods to validate and format text.</a:t>
-            </a:r>
-          </a:p>
-          <a:p>
-            <a:pPr algn="l">
-              <a:lnSpc>
-                <a:spcPts val="6159"/>
-              </a:lnSpc>
-            </a:pPr>
-            <a:r>
-              <a:rPr lang="en-US" sz="4399">
-                <a:solidFill>
-                  <a:srgbClr val="000B3D"/>
-                </a:solidFill>
-                <a:latin typeface="Times New Roman"/>
-                <a:ea typeface="Times New Roman"/>
-                <a:cs typeface="Times New Roman"/>
-                <a:sym typeface="Times New Roman"/>
-              </a:rPr>
-              <a:t>Use find(), replace(), and remove methods to edit text.</a:t>
-            </a:r>
-          </a:p>
-          <a:p>
-            <a:pPr algn="l">
-              <a:lnSpc>
-                <a:spcPts val="6159"/>
-              </a:lnSpc>
-            </a:pPr>
-            <a:r>
-              <a:rPr lang="en-US" sz="4399">
-                <a:solidFill>
-                  <a:srgbClr val="000B3D"/>
-                </a:solidFill>
-                <a:latin typeface="Times New Roman"/>
-                <a:ea typeface="Times New Roman"/>
-                <a:cs typeface="Times New Roman"/>
-                <a:sym typeface="Times New Roman"/>
-              </a:rPr>
-              <a:t>Use split() and join() to move between strings and lists.</a:t>
+            <a:r>
+              <a:rPr sz="3500" dirty="0">
+                <a:latin typeface="Times New Roman" panose="02020603050405020304" pitchFamily="18" charset="0"/>
+                <a:cs typeface="Times New Roman" panose="02020603050405020304" pitchFamily="18" charset="0"/>
+              </a:rPr>
+              <a:t>Open practice_ch10.py in IDLE.</a:t>
+            </a:r>
+          </a:p>
+          <a:p>
+            <a:r>
+              <a:rPr sz="3500" dirty="0">
+                <a:latin typeface="Times New Roman" panose="02020603050405020304" pitchFamily="18" charset="0"/>
+                <a:cs typeface="Times New Roman" panose="02020603050405020304" pitchFamily="18" charset="0"/>
+              </a:rPr>
+              <a:t>Run the file with F5.</a:t>
+            </a:r>
+          </a:p>
+          <a:p>
+            <a:r>
+              <a:rPr sz="3500" dirty="0">
+                <a:latin typeface="Times New Roman" panose="02020603050405020304" pitchFamily="18" charset="0"/>
+                <a:cs typeface="Times New Roman" panose="02020603050405020304" pitchFamily="18" charset="0"/>
+              </a:rPr>
+              <a:t>Practice the Chapter 10 string skills from the lesson.</a:t>
+            </a:r>
+          </a:p>
+        </p:txBody>
+      </p:sp>
+      <p:sp>
+        <p:nvSpPr>
+          <p:cNvPr id="7" name="TextBox 7"/>
+          <p:cNvSpPr txBox="1"/>
+          <p:nvPr/>
+        </p:nvSpPr>
+        <p:spPr>
+          <a:xfrm>
+            <a:off x="10591800" y="3467100"/>
+            <a:ext cx="5628356" cy="3693319"/>
+          </a:xfrm>
+          <a:prstGeom prst="rect">
+            <a:avLst/>
+          </a:prstGeom>
+        </p:spPr>
+        <p:txBody>
+          <a:bodyPr lIns="0" tIns="0" rIns="0" bIns="0" rtlCol="0" anchor="t">
+            <a:spAutoFit/>
+          </a:bodyPr>
+          <a:lstStyle/>
+          <a:p>
+            <a:r>
+              <a:rPr sz="3000" dirty="0">
+                <a:solidFill>
+                  <a:schemeClr val="bg1"/>
+                </a:solidFill>
+                <a:latin typeface="Times New Roman" panose="02020603050405020304" pitchFamily="18" charset="0"/>
+                <a:cs typeface="Times New Roman" panose="02020603050405020304" pitchFamily="18" charset="0"/>
+              </a:rPr>
+              <a:t>Practice includes:</a:t>
+            </a:r>
+          </a:p>
+          <a:p>
+            <a:endParaRPr sz="3000" dirty="0">
+              <a:solidFill>
+                <a:schemeClr val="bg1"/>
+              </a:solidFill>
+              <a:latin typeface="Times New Roman" panose="02020603050405020304" pitchFamily="18" charset="0"/>
+              <a:cs typeface="Times New Roman" panose="02020603050405020304" pitchFamily="18" charset="0"/>
+            </a:endParaRPr>
+          </a:p>
+          <a:p>
+            <a:r>
+              <a:rPr sz="3000" dirty="0">
+                <a:solidFill>
+                  <a:schemeClr val="bg1"/>
+                </a:solidFill>
+                <a:latin typeface="Times New Roman" panose="02020603050405020304" pitchFamily="18" charset="0"/>
+                <a:cs typeface="Times New Roman" panose="02020603050405020304" pitchFamily="18" charset="0"/>
+              </a:rPr>
+              <a:t>• Indexing and slicing</a:t>
+            </a:r>
+          </a:p>
+          <a:p>
+            <a:r>
+              <a:rPr sz="3000" dirty="0">
+                <a:solidFill>
+                  <a:schemeClr val="bg1"/>
+                </a:solidFill>
+                <a:latin typeface="Times New Roman" panose="02020603050405020304" pitchFamily="18" charset="0"/>
+                <a:cs typeface="Times New Roman" panose="02020603050405020304" pitchFamily="18" charset="0"/>
+              </a:rPr>
+              <a:t>• Searching with in</a:t>
+            </a:r>
+          </a:p>
+          <a:p>
+            <a:r>
+              <a:rPr sz="3000" dirty="0">
+                <a:solidFill>
+                  <a:schemeClr val="bg1"/>
+                </a:solidFill>
+                <a:latin typeface="Times New Roman" panose="02020603050405020304" pitchFamily="18" charset="0"/>
+                <a:cs typeface="Times New Roman" panose="02020603050405020304" pitchFamily="18" charset="0"/>
+              </a:rPr>
+              <a:t>• String methods</a:t>
+            </a:r>
+          </a:p>
+          <a:p>
+            <a:r>
+              <a:rPr sz="3000" dirty="0">
+                <a:solidFill>
+                  <a:schemeClr val="bg1"/>
+                </a:solidFill>
+                <a:latin typeface="Times New Roman" panose="02020603050405020304" pitchFamily="18" charset="0"/>
+                <a:cs typeface="Times New Roman" panose="02020603050405020304" pitchFamily="18" charset="0"/>
+              </a:rPr>
+              <a:t>• find() and replace()</a:t>
+            </a:r>
+          </a:p>
+          <a:p>
+            <a:r>
+              <a:rPr sz="3000" dirty="0">
+                <a:solidFill>
+                  <a:schemeClr val="bg1"/>
+                </a:solidFill>
+                <a:latin typeface="Times New Roman" panose="02020603050405020304" pitchFamily="18" charset="0"/>
+                <a:cs typeface="Times New Roman" panose="02020603050405020304" pitchFamily="18" charset="0"/>
+              </a:rPr>
+              <a:t>• split()</a:t>
+            </a:r>
+          </a:p>
+          <a:p>
+            <a:r>
+              <a:rPr sz="3000" dirty="0">
+                <a:solidFill>
+                  <a:schemeClr val="bg1"/>
+                </a:solidFill>
+                <a:latin typeface="Times New Roman" panose="02020603050405020304" pitchFamily="18" charset="0"/>
+                <a:cs typeface="Times New Roman" panose="02020603050405020304" pitchFamily="18" charset="0"/>
+              </a:rPr>
+              <a:t>• join()</a:t>
             </a:r>
           </a:p>
         </p:txBody>

</xml_diff>

<commit_message>
Update Chapter 10 to 13 presentation slides
</commit_message>
<xml_diff>
--- a/slides/chapter_10_How_to_Work_with_Strings.pptx
+++ b/slides/chapter_10_How_to_Work_with_Strings.pptx
@@ -4,6 +4,9 @@
   <p:sldMasterIdLst>
     <p:sldMasterId id="2147483648" r:id="rId1"/>
   </p:sldMasterIdLst>
+  <p:notesMasterIdLst>
+    <p:notesMasterId r:id="rId12"/>
+  </p:notesMasterIdLst>
   <p:sldIdLst>
     <p:sldId id="256" r:id="rId2"/>
     <p:sldId id="257" r:id="rId3"/>
@@ -21,8 +24,8 @@
   <p:embeddedFontLst>
     <p:embeddedFont>
       <p:font typeface="Times New Roman Bold" panose="02020803070505020304" pitchFamily="18" charset="0"/>
-      <p:regular r:id="rId12"/>
-      <p:bold r:id="rId13"/>
+      <p:regular r:id="rId13"/>
+      <p:bold r:id="rId14"/>
     </p:embeddedFont>
   </p:embeddedFontLst>
   <p:defaultTextStyle>
@@ -258,6 +261,1112 @@
 </pc:chgInfo>
 </file>
 
+<file path=ppt/notesMasters/notesMaster1.xml><?xml version="1.0" encoding="utf-8"?>
+<p:notesMaster xmlns:a="http://schemas.openxmlformats.org/drawingml/2006/main" xmlns:r="http://schemas.openxmlformats.org/officeDocument/2006/relationships" xmlns:p="http://schemas.openxmlformats.org/presentationml/2006/main">
+  <p:cSld>
+    <p:bg>
+      <p:bgRef idx="1001">
+        <a:schemeClr val="bg1"/>
+      </p:bgRef>
+    </p:bg>
+    <p:spTree>
+      <p:nvGrpSpPr>
+        <p:cNvPr id="1" name=""/>
+        <p:cNvGrpSpPr/>
+        <p:nvPr/>
+      </p:nvGrpSpPr>
+      <p:grpSpPr>
+        <a:xfrm>
+          <a:off x="0" y="0"/>
+          <a:ext cx="0" cy="0"/>
+          <a:chOff x="0" y="0"/>
+          <a:chExt cx="0" cy="0"/>
+        </a:xfrm>
+      </p:grpSpPr>
+      <p:sp>
+        <p:nvSpPr>
+          <p:cNvPr id="2" name="Header Placeholder 1"/>
+          <p:cNvSpPr>
+            <a:spLocks noGrp="1"/>
+          </p:cNvSpPr>
+          <p:nvPr>
+            <p:ph type="hdr" sz="quarter"/>
+          </p:nvPr>
+        </p:nvSpPr>
+        <p:spPr>
+          <a:xfrm>
+            <a:off x="0" y="0"/>
+            <a:ext cx="2971800" cy="458788"/>
+          </a:xfrm>
+          <a:prstGeom prst="rect">
+            <a:avLst/>
+          </a:prstGeom>
+        </p:spPr>
+        <p:txBody>
+          <a:bodyPr vert="horz" lIns="91440" tIns="45720" rIns="91440" bIns="45720" rtlCol="0"/>
+          <a:lstStyle>
+            <a:lvl1pPr algn="l">
+              <a:defRPr sz="1200"/>
+            </a:lvl1pPr>
+          </a:lstStyle>
+          <a:p>
+            <a:endParaRPr lang="zh-TW" altLang="en-US"/>
+          </a:p>
+        </p:txBody>
+      </p:sp>
+      <p:sp>
+        <p:nvSpPr>
+          <p:cNvPr id="3" name="Date Placeholder 2"/>
+          <p:cNvSpPr>
+            <a:spLocks noGrp="1"/>
+          </p:cNvSpPr>
+          <p:nvPr>
+            <p:ph type="dt" idx="1"/>
+          </p:nvPr>
+        </p:nvSpPr>
+        <p:spPr>
+          <a:xfrm>
+            <a:off x="3884613" y="0"/>
+            <a:ext cx="2971800" cy="458788"/>
+          </a:xfrm>
+          <a:prstGeom prst="rect">
+            <a:avLst/>
+          </a:prstGeom>
+        </p:spPr>
+        <p:txBody>
+          <a:bodyPr vert="horz" lIns="91440" tIns="45720" rIns="91440" bIns="45720" rtlCol="0"/>
+          <a:lstStyle>
+            <a:lvl1pPr algn="r">
+              <a:defRPr sz="1200"/>
+            </a:lvl1pPr>
+          </a:lstStyle>
+          <a:p>
+            <a:fld id="{C5B92856-7F4D-4C29-9C58-10799B6E7057}" type="datetimeFigureOut">
+              <a:rPr lang="zh-TW" altLang="en-US" smtClean="0"/>
+              <a:t>2026/10/1</a:t>
+            </a:fld>
+            <a:endParaRPr lang="zh-TW" altLang="en-US"/>
+          </a:p>
+        </p:txBody>
+      </p:sp>
+      <p:sp>
+        <p:nvSpPr>
+          <p:cNvPr id="4" name="Slide Image Placeholder 3"/>
+          <p:cNvSpPr>
+            <a:spLocks noGrp="1" noRot="1" noChangeAspect="1"/>
+          </p:cNvSpPr>
+          <p:nvPr>
+            <p:ph type="sldImg" idx="2"/>
+          </p:nvPr>
+        </p:nvSpPr>
+        <p:spPr>
+          <a:xfrm>
+            <a:off x="685800" y="1143000"/>
+            <a:ext cx="5486400" cy="3086100"/>
+          </a:xfrm>
+          <a:prstGeom prst="rect">
+            <a:avLst/>
+          </a:prstGeom>
+          <a:noFill/>
+          <a:ln w="12700">
+            <a:solidFill>
+              <a:prstClr val="black"/>
+            </a:solidFill>
+          </a:ln>
+        </p:spPr>
+        <p:txBody>
+          <a:bodyPr vert="horz" lIns="91440" tIns="45720" rIns="91440" bIns="45720" rtlCol="0" anchor="ctr"/>
+          <a:lstStyle/>
+          <a:p>
+            <a:endParaRPr lang="zh-TW" altLang="en-US"/>
+          </a:p>
+        </p:txBody>
+      </p:sp>
+      <p:sp>
+        <p:nvSpPr>
+          <p:cNvPr id="5" name="Notes Placeholder 4"/>
+          <p:cNvSpPr>
+            <a:spLocks noGrp="1"/>
+          </p:cNvSpPr>
+          <p:nvPr>
+            <p:ph type="body" sz="quarter" idx="3"/>
+          </p:nvPr>
+        </p:nvSpPr>
+        <p:spPr>
+          <a:xfrm>
+            <a:off x="685800" y="4400550"/>
+            <a:ext cx="5486400" cy="3600450"/>
+          </a:xfrm>
+          <a:prstGeom prst="rect">
+            <a:avLst/>
+          </a:prstGeom>
+        </p:spPr>
+        <p:txBody>
+          <a:bodyPr vert="horz" lIns="91440" tIns="45720" rIns="91440" bIns="45720" rtlCol="0"/>
+          <a:lstStyle/>
+          <a:p>
+            <a:pPr lvl="0"/>
+            <a:r>
+              <a:rPr lang="en-US" altLang="zh-TW"/>
+              <a:t>Click to edit Master text styles</a:t>
+            </a:r>
+          </a:p>
+          <a:p>
+            <a:pPr lvl="1"/>
+            <a:r>
+              <a:rPr lang="en-US" altLang="zh-TW"/>
+              <a:t>Second level</a:t>
+            </a:r>
+          </a:p>
+          <a:p>
+            <a:pPr lvl="2"/>
+            <a:r>
+              <a:rPr lang="en-US" altLang="zh-TW"/>
+              <a:t>Third level</a:t>
+            </a:r>
+          </a:p>
+          <a:p>
+            <a:pPr lvl="3"/>
+            <a:r>
+              <a:rPr lang="en-US" altLang="zh-TW"/>
+              <a:t>Fourth level</a:t>
+            </a:r>
+          </a:p>
+          <a:p>
+            <a:pPr lvl="4"/>
+            <a:r>
+              <a:rPr lang="en-US" altLang="zh-TW"/>
+              <a:t>Fifth level</a:t>
+            </a:r>
+            <a:endParaRPr lang="zh-TW" altLang="en-US"/>
+          </a:p>
+        </p:txBody>
+      </p:sp>
+      <p:sp>
+        <p:nvSpPr>
+          <p:cNvPr id="6" name="Footer Placeholder 5"/>
+          <p:cNvSpPr>
+            <a:spLocks noGrp="1"/>
+          </p:cNvSpPr>
+          <p:nvPr>
+            <p:ph type="ftr" sz="quarter" idx="4"/>
+          </p:nvPr>
+        </p:nvSpPr>
+        <p:spPr>
+          <a:xfrm>
+            <a:off x="0" y="8685213"/>
+            <a:ext cx="2971800" cy="458787"/>
+          </a:xfrm>
+          <a:prstGeom prst="rect">
+            <a:avLst/>
+          </a:prstGeom>
+        </p:spPr>
+        <p:txBody>
+          <a:bodyPr vert="horz" lIns="91440" tIns="45720" rIns="91440" bIns="45720" rtlCol="0" anchor="b"/>
+          <a:lstStyle>
+            <a:lvl1pPr algn="l">
+              <a:defRPr sz="1200"/>
+            </a:lvl1pPr>
+          </a:lstStyle>
+          <a:p>
+            <a:endParaRPr lang="zh-TW" altLang="en-US"/>
+          </a:p>
+        </p:txBody>
+      </p:sp>
+      <p:sp>
+        <p:nvSpPr>
+          <p:cNvPr id="7" name="Slide Number Placeholder 6"/>
+          <p:cNvSpPr>
+            <a:spLocks noGrp="1"/>
+          </p:cNvSpPr>
+          <p:nvPr>
+            <p:ph type="sldNum" sz="quarter" idx="5"/>
+          </p:nvPr>
+        </p:nvSpPr>
+        <p:spPr>
+          <a:xfrm>
+            <a:off x="3884613" y="8685213"/>
+            <a:ext cx="2971800" cy="458787"/>
+          </a:xfrm>
+          <a:prstGeom prst="rect">
+            <a:avLst/>
+          </a:prstGeom>
+        </p:spPr>
+        <p:txBody>
+          <a:bodyPr vert="horz" lIns="91440" tIns="45720" rIns="91440" bIns="45720" rtlCol="0" anchor="b"/>
+          <a:lstStyle>
+            <a:lvl1pPr algn="r">
+              <a:defRPr sz="1200"/>
+            </a:lvl1pPr>
+          </a:lstStyle>
+          <a:p>
+            <a:fld id="{7B37A861-61C3-4844-9E8F-4F4FC7449C66}" type="slidenum">
+              <a:rPr lang="zh-TW" altLang="en-US" smtClean="0"/>
+              <a:t>‹#›</a:t>
+            </a:fld>
+            <a:endParaRPr lang="zh-TW" altLang="en-US"/>
+          </a:p>
+        </p:txBody>
+      </p:sp>
+    </p:spTree>
+    <p:extLst>
+      <p:ext uri="{BB962C8B-B14F-4D97-AF65-F5344CB8AC3E}">
+        <p14:creationId xmlns:p14="http://schemas.microsoft.com/office/powerpoint/2010/main" val="3357795770"/>
+      </p:ext>
+    </p:extLst>
+  </p:cSld>
+  <p:clrMap bg1="lt1" tx1="dk1" bg2="lt2" tx2="dk2" accent1="accent1" accent2="accent2" accent3="accent3" accent4="accent4" accent5="accent5" accent6="accent6" hlink="hlink" folHlink="folHlink"/>
+  <p:notesStyle>
+    <a:lvl1pPr marL="0" algn="l" defTabSz="914400" rtl="0" eaLnBrk="1" latinLnBrk="0" hangingPunct="1">
+      <a:defRPr sz="1200" kern="1200">
+        <a:solidFill>
+          <a:schemeClr val="tx1"/>
+        </a:solidFill>
+        <a:latin typeface="+mn-lt"/>
+        <a:ea typeface="+mn-ea"/>
+        <a:cs typeface="+mn-cs"/>
+      </a:defRPr>
+    </a:lvl1pPr>
+    <a:lvl2pPr marL="457200" algn="l" defTabSz="914400" rtl="0" eaLnBrk="1" latinLnBrk="0" hangingPunct="1">
+      <a:defRPr sz="1200" kern="1200">
+        <a:solidFill>
+          <a:schemeClr val="tx1"/>
+        </a:solidFill>
+        <a:latin typeface="+mn-lt"/>
+        <a:ea typeface="+mn-ea"/>
+        <a:cs typeface="+mn-cs"/>
+      </a:defRPr>
+    </a:lvl2pPr>
+    <a:lvl3pPr marL="914400" algn="l" defTabSz="914400" rtl="0" eaLnBrk="1" latinLnBrk="0" hangingPunct="1">
+      <a:defRPr sz="1200" kern="1200">
+        <a:solidFill>
+          <a:schemeClr val="tx1"/>
+        </a:solidFill>
+        <a:latin typeface="+mn-lt"/>
+        <a:ea typeface="+mn-ea"/>
+        <a:cs typeface="+mn-cs"/>
+      </a:defRPr>
+    </a:lvl3pPr>
+    <a:lvl4pPr marL="1371600" algn="l" defTabSz="914400" rtl="0" eaLnBrk="1" latinLnBrk="0" hangingPunct="1">
+      <a:defRPr sz="1200" kern="1200">
+        <a:solidFill>
+          <a:schemeClr val="tx1"/>
+        </a:solidFill>
+        <a:latin typeface="+mn-lt"/>
+        <a:ea typeface="+mn-ea"/>
+        <a:cs typeface="+mn-cs"/>
+      </a:defRPr>
+    </a:lvl4pPr>
+    <a:lvl5pPr marL="1828800" algn="l" defTabSz="914400" rtl="0" eaLnBrk="1" latinLnBrk="0" hangingPunct="1">
+      <a:defRPr sz="1200" kern="1200">
+        <a:solidFill>
+          <a:schemeClr val="tx1"/>
+        </a:solidFill>
+        <a:latin typeface="+mn-lt"/>
+        <a:ea typeface="+mn-ea"/>
+        <a:cs typeface="+mn-cs"/>
+      </a:defRPr>
+    </a:lvl5pPr>
+    <a:lvl6pPr marL="2286000" algn="l" defTabSz="914400" rtl="0" eaLnBrk="1" latinLnBrk="0" hangingPunct="1">
+      <a:defRPr sz="1200" kern="1200">
+        <a:solidFill>
+          <a:schemeClr val="tx1"/>
+        </a:solidFill>
+        <a:latin typeface="+mn-lt"/>
+        <a:ea typeface="+mn-ea"/>
+        <a:cs typeface="+mn-cs"/>
+      </a:defRPr>
+    </a:lvl6pPr>
+    <a:lvl7pPr marL="2743200" algn="l" defTabSz="914400" rtl="0" eaLnBrk="1" latinLnBrk="0" hangingPunct="1">
+      <a:defRPr sz="1200" kern="1200">
+        <a:solidFill>
+          <a:schemeClr val="tx1"/>
+        </a:solidFill>
+        <a:latin typeface="+mn-lt"/>
+        <a:ea typeface="+mn-ea"/>
+        <a:cs typeface="+mn-cs"/>
+      </a:defRPr>
+    </a:lvl7pPr>
+    <a:lvl8pPr marL="3200400" algn="l" defTabSz="914400" rtl="0" eaLnBrk="1" latinLnBrk="0" hangingPunct="1">
+      <a:defRPr sz="1200" kern="1200">
+        <a:solidFill>
+          <a:schemeClr val="tx1"/>
+        </a:solidFill>
+        <a:latin typeface="+mn-lt"/>
+        <a:ea typeface="+mn-ea"/>
+        <a:cs typeface="+mn-cs"/>
+      </a:defRPr>
+    </a:lvl8pPr>
+    <a:lvl9pPr marL="3657600" algn="l" defTabSz="914400" rtl="0" eaLnBrk="1" latinLnBrk="0" hangingPunct="1">
+      <a:defRPr sz="1200" kern="1200">
+        <a:solidFill>
+          <a:schemeClr val="tx1"/>
+        </a:solidFill>
+        <a:latin typeface="+mn-lt"/>
+        <a:ea typeface="+mn-ea"/>
+        <a:cs typeface="+mn-cs"/>
+      </a:defRPr>
+    </a:lvl9pPr>
+  </p:notesStyle>
+</p:notesMaster>
+</file>
+
+<file path=ppt/notesSlides/notesSlide1.xml><?xml version="1.0" encoding="utf-8"?>
+<p:notes xmlns:a="http://schemas.openxmlformats.org/drawingml/2006/main" xmlns:r="http://schemas.openxmlformats.org/officeDocument/2006/relationships" xmlns:p="http://schemas.openxmlformats.org/presentationml/2006/main">
+  <p:cSld>
+    <p:spTree>
+      <p:nvGrpSpPr>
+        <p:cNvPr id="1" name=""/>
+        <p:cNvGrpSpPr/>
+        <p:nvPr/>
+      </p:nvGrpSpPr>
+      <p:grpSpPr>
+        <a:xfrm>
+          <a:off x="0" y="0"/>
+          <a:ext cx="0" cy="0"/>
+          <a:chOff x="0" y="0"/>
+          <a:chExt cx="0" cy="0"/>
+        </a:xfrm>
+      </p:grpSpPr>
+      <p:sp>
+        <p:nvSpPr>
+          <p:cNvPr id="2" name="Slide Image Placeholder 1"/>
+          <p:cNvSpPr>
+            <a:spLocks noGrp="1" noRot="1" noChangeAspect="1"/>
+          </p:cNvSpPr>
+          <p:nvPr>
+            <p:ph type="sldImg"/>
+          </p:nvPr>
+        </p:nvSpPr>
+        <p:spPr/>
+      </p:sp>
+      <p:sp>
+        <p:nvSpPr>
+          <p:cNvPr id="3" name="Notes Placeholder 2"/>
+          <p:cNvSpPr>
+            <a:spLocks noGrp="1"/>
+          </p:cNvSpPr>
+          <p:nvPr>
+            <p:ph type="body" idx="1"/>
+          </p:nvPr>
+        </p:nvSpPr>
+        <p:spPr/>
+        <p:txBody>
+          <a:bodyPr/>
+          <a:lstStyle/>
+          <a:p>
+            <a:endParaRPr lang="zh-TW" altLang="en-US" dirty="0"/>
+          </a:p>
+        </p:txBody>
+      </p:sp>
+      <p:sp>
+        <p:nvSpPr>
+          <p:cNvPr id="4" name="Slide Number Placeholder 3"/>
+          <p:cNvSpPr>
+            <a:spLocks noGrp="1"/>
+          </p:cNvSpPr>
+          <p:nvPr>
+            <p:ph type="sldNum" sz="quarter" idx="5"/>
+          </p:nvPr>
+        </p:nvSpPr>
+        <p:spPr/>
+        <p:txBody>
+          <a:bodyPr/>
+          <a:lstStyle/>
+          <a:p>
+            <a:fld id="{7B37A861-61C3-4844-9E8F-4F4FC7449C66}" type="slidenum">
+              <a:rPr lang="zh-TW" altLang="en-US" smtClean="0"/>
+              <a:t>1</a:t>
+            </a:fld>
+            <a:endParaRPr lang="zh-TW" altLang="en-US"/>
+          </a:p>
+        </p:txBody>
+      </p:sp>
+    </p:spTree>
+    <p:extLst>
+      <p:ext uri="{BB962C8B-B14F-4D97-AF65-F5344CB8AC3E}">
+        <p14:creationId xmlns:p14="http://schemas.microsoft.com/office/powerpoint/2010/main" val="75190909"/>
+      </p:ext>
+    </p:extLst>
+  </p:cSld>
+  <p:clrMapOvr>
+    <a:masterClrMapping/>
+  </p:clrMapOvr>
+</p:notes>
+</file>
+
+<file path=ppt/notesSlides/notesSlide2.xml><?xml version="1.0" encoding="utf-8"?>
+<p:notes xmlns:a="http://schemas.openxmlformats.org/drawingml/2006/main" xmlns:r="http://schemas.openxmlformats.org/officeDocument/2006/relationships" xmlns:p="http://schemas.openxmlformats.org/presentationml/2006/main">
+  <p:cSld>
+    <p:spTree>
+      <p:nvGrpSpPr>
+        <p:cNvPr id="1" name=""/>
+        <p:cNvGrpSpPr/>
+        <p:nvPr/>
+      </p:nvGrpSpPr>
+      <p:grpSpPr>
+        <a:xfrm>
+          <a:off x="0" y="0"/>
+          <a:ext cx="0" cy="0"/>
+          <a:chOff x="0" y="0"/>
+          <a:chExt cx="0" cy="0"/>
+        </a:xfrm>
+      </p:grpSpPr>
+      <p:sp>
+        <p:nvSpPr>
+          <p:cNvPr id="2" name="Slide Image Placeholder 1"/>
+          <p:cNvSpPr>
+            <a:spLocks noGrp="1" noRot="1" noChangeAspect="1"/>
+          </p:cNvSpPr>
+          <p:nvPr>
+            <p:ph type="sldImg"/>
+          </p:nvPr>
+        </p:nvSpPr>
+        <p:spPr/>
+      </p:sp>
+      <p:sp>
+        <p:nvSpPr>
+          <p:cNvPr id="3" name="Notes Placeholder 2"/>
+          <p:cNvSpPr>
+            <a:spLocks noGrp="1"/>
+          </p:cNvSpPr>
+          <p:nvPr>
+            <p:ph type="body" idx="1"/>
+          </p:nvPr>
+        </p:nvSpPr>
+        <p:spPr/>
+        <p:txBody>
+          <a:bodyPr/>
+          <a:lstStyle/>
+          <a:p>
+            <a:endParaRPr lang="zh-TW" altLang="en-US" dirty="0"/>
+          </a:p>
+        </p:txBody>
+      </p:sp>
+      <p:sp>
+        <p:nvSpPr>
+          <p:cNvPr id="4" name="Slide Number Placeholder 3"/>
+          <p:cNvSpPr>
+            <a:spLocks noGrp="1"/>
+          </p:cNvSpPr>
+          <p:nvPr>
+            <p:ph type="sldNum" sz="quarter" idx="5"/>
+          </p:nvPr>
+        </p:nvSpPr>
+        <p:spPr/>
+        <p:txBody>
+          <a:bodyPr/>
+          <a:lstStyle/>
+          <a:p>
+            <a:fld id="{7B37A861-61C3-4844-9E8F-4F4FC7449C66}" type="slidenum">
+              <a:rPr lang="zh-TW" altLang="en-US" smtClean="0"/>
+              <a:t>2</a:t>
+            </a:fld>
+            <a:endParaRPr lang="zh-TW" altLang="en-US"/>
+          </a:p>
+        </p:txBody>
+      </p:sp>
+    </p:spTree>
+    <p:extLst>
+      <p:ext uri="{BB962C8B-B14F-4D97-AF65-F5344CB8AC3E}">
+        <p14:creationId xmlns:p14="http://schemas.microsoft.com/office/powerpoint/2010/main" val="1737946061"/>
+      </p:ext>
+    </p:extLst>
+  </p:cSld>
+  <p:clrMapOvr>
+    <a:masterClrMapping/>
+  </p:clrMapOvr>
+</p:notes>
+</file>
+
+<file path=ppt/notesSlides/notesSlide3.xml><?xml version="1.0" encoding="utf-8"?>
+<p:notes xmlns:a="http://schemas.openxmlformats.org/drawingml/2006/main" xmlns:r="http://schemas.openxmlformats.org/officeDocument/2006/relationships" xmlns:p="http://schemas.openxmlformats.org/presentationml/2006/main">
+  <p:cSld>
+    <p:spTree>
+      <p:nvGrpSpPr>
+        <p:cNvPr id="1" name=""/>
+        <p:cNvGrpSpPr/>
+        <p:nvPr/>
+      </p:nvGrpSpPr>
+      <p:grpSpPr>
+        <a:xfrm>
+          <a:off x="0" y="0"/>
+          <a:ext cx="0" cy="0"/>
+          <a:chOff x="0" y="0"/>
+          <a:chExt cx="0" cy="0"/>
+        </a:xfrm>
+      </p:grpSpPr>
+      <p:sp>
+        <p:nvSpPr>
+          <p:cNvPr id="2" name="Slide Image Placeholder 1"/>
+          <p:cNvSpPr>
+            <a:spLocks noGrp="1" noRot="1" noChangeAspect="1"/>
+          </p:cNvSpPr>
+          <p:nvPr>
+            <p:ph type="sldImg"/>
+          </p:nvPr>
+        </p:nvSpPr>
+        <p:spPr/>
+      </p:sp>
+      <p:sp>
+        <p:nvSpPr>
+          <p:cNvPr id="3" name="Notes Placeholder 2"/>
+          <p:cNvSpPr>
+            <a:spLocks noGrp="1"/>
+          </p:cNvSpPr>
+          <p:nvPr>
+            <p:ph type="body" idx="1"/>
+          </p:nvPr>
+        </p:nvSpPr>
+        <p:spPr/>
+        <p:txBody>
+          <a:bodyPr/>
+          <a:lstStyle/>
+          <a:p>
+            <a:endParaRPr lang="zh-TW" altLang="en-US" dirty="0"/>
+          </a:p>
+        </p:txBody>
+      </p:sp>
+      <p:sp>
+        <p:nvSpPr>
+          <p:cNvPr id="4" name="Slide Number Placeholder 3"/>
+          <p:cNvSpPr>
+            <a:spLocks noGrp="1"/>
+          </p:cNvSpPr>
+          <p:nvPr>
+            <p:ph type="sldNum" sz="quarter" idx="5"/>
+          </p:nvPr>
+        </p:nvSpPr>
+        <p:spPr/>
+        <p:txBody>
+          <a:bodyPr/>
+          <a:lstStyle/>
+          <a:p>
+            <a:fld id="{7B37A861-61C3-4844-9E8F-4F4FC7449C66}" type="slidenum">
+              <a:rPr lang="zh-TW" altLang="en-US" smtClean="0"/>
+              <a:t>3</a:t>
+            </a:fld>
+            <a:endParaRPr lang="zh-TW" altLang="en-US"/>
+          </a:p>
+        </p:txBody>
+      </p:sp>
+    </p:spTree>
+    <p:extLst>
+      <p:ext uri="{BB962C8B-B14F-4D97-AF65-F5344CB8AC3E}">
+        <p14:creationId xmlns:p14="http://schemas.microsoft.com/office/powerpoint/2010/main" val="3389919361"/>
+      </p:ext>
+    </p:extLst>
+  </p:cSld>
+  <p:clrMapOvr>
+    <a:masterClrMapping/>
+  </p:clrMapOvr>
+</p:notes>
+</file>
+
+<file path=ppt/notesSlides/notesSlide4.xml><?xml version="1.0" encoding="utf-8"?>
+<p:notes xmlns:a="http://schemas.openxmlformats.org/drawingml/2006/main" xmlns:r="http://schemas.openxmlformats.org/officeDocument/2006/relationships" xmlns:p="http://schemas.openxmlformats.org/presentationml/2006/main">
+  <p:cSld>
+    <p:spTree>
+      <p:nvGrpSpPr>
+        <p:cNvPr id="1" name=""/>
+        <p:cNvGrpSpPr/>
+        <p:nvPr/>
+      </p:nvGrpSpPr>
+      <p:grpSpPr>
+        <a:xfrm>
+          <a:off x="0" y="0"/>
+          <a:ext cx="0" cy="0"/>
+          <a:chOff x="0" y="0"/>
+          <a:chExt cx="0" cy="0"/>
+        </a:xfrm>
+      </p:grpSpPr>
+      <p:sp>
+        <p:nvSpPr>
+          <p:cNvPr id="2" name="Slide Image Placeholder 1"/>
+          <p:cNvSpPr>
+            <a:spLocks noGrp="1" noRot="1" noChangeAspect="1"/>
+          </p:cNvSpPr>
+          <p:nvPr>
+            <p:ph type="sldImg"/>
+          </p:nvPr>
+        </p:nvSpPr>
+        <p:spPr/>
+      </p:sp>
+      <p:sp>
+        <p:nvSpPr>
+          <p:cNvPr id="3" name="Notes Placeholder 2"/>
+          <p:cNvSpPr>
+            <a:spLocks noGrp="1"/>
+          </p:cNvSpPr>
+          <p:nvPr>
+            <p:ph type="body" idx="1"/>
+          </p:nvPr>
+        </p:nvSpPr>
+        <p:spPr/>
+        <p:txBody>
+          <a:bodyPr/>
+          <a:lstStyle/>
+          <a:p>
+            <a:endParaRPr lang="zh-TW" altLang="en-US" dirty="0"/>
+          </a:p>
+        </p:txBody>
+      </p:sp>
+      <p:sp>
+        <p:nvSpPr>
+          <p:cNvPr id="4" name="Slide Number Placeholder 3"/>
+          <p:cNvSpPr>
+            <a:spLocks noGrp="1"/>
+          </p:cNvSpPr>
+          <p:nvPr>
+            <p:ph type="sldNum" sz="quarter" idx="5"/>
+          </p:nvPr>
+        </p:nvSpPr>
+        <p:spPr/>
+        <p:txBody>
+          <a:bodyPr/>
+          <a:lstStyle/>
+          <a:p>
+            <a:fld id="{7B37A861-61C3-4844-9E8F-4F4FC7449C66}" type="slidenum">
+              <a:rPr lang="zh-TW" altLang="en-US" smtClean="0"/>
+              <a:t>4</a:t>
+            </a:fld>
+            <a:endParaRPr lang="zh-TW" altLang="en-US"/>
+          </a:p>
+        </p:txBody>
+      </p:sp>
+    </p:spTree>
+    <p:extLst>
+      <p:ext uri="{BB962C8B-B14F-4D97-AF65-F5344CB8AC3E}">
+        <p14:creationId xmlns:p14="http://schemas.microsoft.com/office/powerpoint/2010/main" val="1707334775"/>
+      </p:ext>
+    </p:extLst>
+  </p:cSld>
+  <p:clrMapOvr>
+    <a:masterClrMapping/>
+  </p:clrMapOvr>
+</p:notes>
+</file>
+
+<file path=ppt/notesSlides/notesSlide5.xml><?xml version="1.0" encoding="utf-8"?>
+<p:notes xmlns:a="http://schemas.openxmlformats.org/drawingml/2006/main" xmlns:r="http://schemas.openxmlformats.org/officeDocument/2006/relationships" xmlns:p="http://schemas.openxmlformats.org/presentationml/2006/main">
+  <p:cSld>
+    <p:spTree>
+      <p:nvGrpSpPr>
+        <p:cNvPr id="1" name=""/>
+        <p:cNvGrpSpPr/>
+        <p:nvPr/>
+      </p:nvGrpSpPr>
+      <p:grpSpPr>
+        <a:xfrm>
+          <a:off x="0" y="0"/>
+          <a:ext cx="0" cy="0"/>
+          <a:chOff x="0" y="0"/>
+          <a:chExt cx="0" cy="0"/>
+        </a:xfrm>
+      </p:grpSpPr>
+      <p:sp>
+        <p:nvSpPr>
+          <p:cNvPr id="2" name="Slide Image Placeholder 1"/>
+          <p:cNvSpPr>
+            <a:spLocks noGrp="1" noRot="1" noChangeAspect="1"/>
+          </p:cNvSpPr>
+          <p:nvPr>
+            <p:ph type="sldImg"/>
+          </p:nvPr>
+        </p:nvSpPr>
+        <p:spPr/>
+      </p:sp>
+      <p:sp>
+        <p:nvSpPr>
+          <p:cNvPr id="3" name="Notes Placeholder 2"/>
+          <p:cNvSpPr>
+            <a:spLocks noGrp="1"/>
+          </p:cNvSpPr>
+          <p:nvPr>
+            <p:ph type="body" idx="1"/>
+          </p:nvPr>
+        </p:nvSpPr>
+        <p:spPr/>
+        <p:txBody>
+          <a:bodyPr/>
+          <a:lstStyle/>
+          <a:p>
+            <a:endParaRPr lang="zh-TW" altLang="en-US" dirty="0"/>
+          </a:p>
+        </p:txBody>
+      </p:sp>
+      <p:sp>
+        <p:nvSpPr>
+          <p:cNvPr id="4" name="Slide Number Placeholder 3"/>
+          <p:cNvSpPr>
+            <a:spLocks noGrp="1"/>
+          </p:cNvSpPr>
+          <p:nvPr>
+            <p:ph type="sldNum" sz="quarter" idx="5"/>
+          </p:nvPr>
+        </p:nvSpPr>
+        <p:spPr/>
+        <p:txBody>
+          <a:bodyPr/>
+          <a:lstStyle/>
+          <a:p>
+            <a:fld id="{7B37A861-61C3-4844-9E8F-4F4FC7449C66}" type="slidenum">
+              <a:rPr lang="zh-TW" altLang="en-US" smtClean="0"/>
+              <a:t>5</a:t>
+            </a:fld>
+            <a:endParaRPr lang="zh-TW" altLang="en-US"/>
+          </a:p>
+        </p:txBody>
+      </p:sp>
+    </p:spTree>
+    <p:extLst>
+      <p:ext uri="{BB962C8B-B14F-4D97-AF65-F5344CB8AC3E}">
+        <p14:creationId xmlns:p14="http://schemas.microsoft.com/office/powerpoint/2010/main" val="982392393"/>
+      </p:ext>
+    </p:extLst>
+  </p:cSld>
+  <p:clrMapOvr>
+    <a:masterClrMapping/>
+  </p:clrMapOvr>
+</p:notes>
+</file>
+
+<file path=ppt/notesSlides/notesSlide6.xml><?xml version="1.0" encoding="utf-8"?>
+<p:notes xmlns:a="http://schemas.openxmlformats.org/drawingml/2006/main" xmlns:r="http://schemas.openxmlformats.org/officeDocument/2006/relationships" xmlns:p="http://schemas.openxmlformats.org/presentationml/2006/main">
+  <p:cSld>
+    <p:spTree>
+      <p:nvGrpSpPr>
+        <p:cNvPr id="1" name=""/>
+        <p:cNvGrpSpPr/>
+        <p:nvPr/>
+      </p:nvGrpSpPr>
+      <p:grpSpPr>
+        <a:xfrm>
+          <a:off x="0" y="0"/>
+          <a:ext cx="0" cy="0"/>
+          <a:chOff x="0" y="0"/>
+          <a:chExt cx="0" cy="0"/>
+        </a:xfrm>
+      </p:grpSpPr>
+      <p:sp>
+        <p:nvSpPr>
+          <p:cNvPr id="2" name="Slide Image Placeholder 1"/>
+          <p:cNvSpPr>
+            <a:spLocks noGrp="1" noRot="1" noChangeAspect="1"/>
+          </p:cNvSpPr>
+          <p:nvPr>
+            <p:ph type="sldImg"/>
+          </p:nvPr>
+        </p:nvSpPr>
+        <p:spPr/>
+      </p:sp>
+      <p:sp>
+        <p:nvSpPr>
+          <p:cNvPr id="3" name="Notes Placeholder 2"/>
+          <p:cNvSpPr>
+            <a:spLocks noGrp="1"/>
+          </p:cNvSpPr>
+          <p:nvPr>
+            <p:ph type="body" idx="1"/>
+          </p:nvPr>
+        </p:nvSpPr>
+        <p:spPr/>
+        <p:txBody>
+          <a:bodyPr/>
+          <a:lstStyle/>
+          <a:p>
+            <a:endParaRPr lang="zh-TW" altLang="en-US" dirty="0"/>
+          </a:p>
+        </p:txBody>
+      </p:sp>
+      <p:sp>
+        <p:nvSpPr>
+          <p:cNvPr id="4" name="Slide Number Placeholder 3"/>
+          <p:cNvSpPr>
+            <a:spLocks noGrp="1"/>
+          </p:cNvSpPr>
+          <p:nvPr>
+            <p:ph type="sldNum" sz="quarter" idx="5"/>
+          </p:nvPr>
+        </p:nvSpPr>
+        <p:spPr/>
+        <p:txBody>
+          <a:bodyPr/>
+          <a:lstStyle/>
+          <a:p>
+            <a:fld id="{7B37A861-61C3-4844-9E8F-4F4FC7449C66}" type="slidenum">
+              <a:rPr lang="zh-TW" altLang="en-US" smtClean="0"/>
+              <a:t>6</a:t>
+            </a:fld>
+            <a:endParaRPr lang="zh-TW" altLang="en-US"/>
+          </a:p>
+        </p:txBody>
+      </p:sp>
+    </p:spTree>
+    <p:extLst>
+      <p:ext uri="{BB962C8B-B14F-4D97-AF65-F5344CB8AC3E}">
+        <p14:creationId xmlns:p14="http://schemas.microsoft.com/office/powerpoint/2010/main" val="2632672647"/>
+      </p:ext>
+    </p:extLst>
+  </p:cSld>
+  <p:clrMapOvr>
+    <a:masterClrMapping/>
+  </p:clrMapOvr>
+</p:notes>
+</file>
+
+<file path=ppt/notesSlides/notesSlide7.xml><?xml version="1.0" encoding="utf-8"?>
+<p:notes xmlns:a="http://schemas.openxmlformats.org/drawingml/2006/main" xmlns:r="http://schemas.openxmlformats.org/officeDocument/2006/relationships" xmlns:p="http://schemas.openxmlformats.org/presentationml/2006/main">
+  <p:cSld>
+    <p:spTree>
+      <p:nvGrpSpPr>
+        <p:cNvPr id="1" name=""/>
+        <p:cNvGrpSpPr/>
+        <p:nvPr/>
+      </p:nvGrpSpPr>
+      <p:grpSpPr>
+        <a:xfrm>
+          <a:off x="0" y="0"/>
+          <a:ext cx="0" cy="0"/>
+          <a:chOff x="0" y="0"/>
+          <a:chExt cx="0" cy="0"/>
+        </a:xfrm>
+      </p:grpSpPr>
+      <p:sp>
+        <p:nvSpPr>
+          <p:cNvPr id="2" name="Slide Image Placeholder 1"/>
+          <p:cNvSpPr>
+            <a:spLocks noGrp="1" noRot="1" noChangeAspect="1"/>
+          </p:cNvSpPr>
+          <p:nvPr>
+            <p:ph type="sldImg"/>
+          </p:nvPr>
+        </p:nvSpPr>
+        <p:spPr/>
+      </p:sp>
+      <p:sp>
+        <p:nvSpPr>
+          <p:cNvPr id="3" name="Notes Placeholder 2"/>
+          <p:cNvSpPr>
+            <a:spLocks noGrp="1"/>
+          </p:cNvSpPr>
+          <p:nvPr>
+            <p:ph type="body" idx="1"/>
+          </p:nvPr>
+        </p:nvSpPr>
+        <p:spPr/>
+        <p:txBody>
+          <a:bodyPr/>
+          <a:lstStyle/>
+          <a:p>
+            <a:endParaRPr lang="zh-TW" altLang="en-US" dirty="0"/>
+          </a:p>
+        </p:txBody>
+      </p:sp>
+      <p:sp>
+        <p:nvSpPr>
+          <p:cNvPr id="4" name="Slide Number Placeholder 3"/>
+          <p:cNvSpPr>
+            <a:spLocks noGrp="1"/>
+          </p:cNvSpPr>
+          <p:nvPr>
+            <p:ph type="sldNum" sz="quarter" idx="5"/>
+          </p:nvPr>
+        </p:nvSpPr>
+        <p:spPr/>
+        <p:txBody>
+          <a:bodyPr/>
+          <a:lstStyle/>
+          <a:p>
+            <a:fld id="{7B37A861-61C3-4844-9E8F-4F4FC7449C66}" type="slidenum">
+              <a:rPr lang="zh-TW" altLang="en-US" smtClean="0"/>
+              <a:t>7</a:t>
+            </a:fld>
+            <a:endParaRPr lang="zh-TW" altLang="en-US"/>
+          </a:p>
+        </p:txBody>
+      </p:sp>
+    </p:spTree>
+    <p:extLst>
+      <p:ext uri="{BB962C8B-B14F-4D97-AF65-F5344CB8AC3E}">
+        <p14:creationId xmlns:p14="http://schemas.microsoft.com/office/powerpoint/2010/main" val="3668676658"/>
+      </p:ext>
+    </p:extLst>
+  </p:cSld>
+  <p:clrMapOvr>
+    <a:masterClrMapping/>
+  </p:clrMapOvr>
+</p:notes>
+</file>
+
+<file path=ppt/notesSlides/notesSlide8.xml><?xml version="1.0" encoding="utf-8"?>
+<p:notes xmlns:a="http://schemas.openxmlformats.org/drawingml/2006/main" xmlns:r="http://schemas.openxmlformats.org/officeDocument/2006/relationships" xmlns:p="http://schemas.openxmlformats.org/presentationml/2006/main">
+  <p:cSld>
+    <p:spTree>
+      <p:nvGrpSpPr>
+        <p:cNvPr id="1" name=""/>
+        <p:cNvGrpSpPr/>
+        <p:nvPr/>
+      </p:nvGrpSpPr>
+      <p:grpSpPr>
+        <a:xfrm>
+          <a:off x="0" y="0"/>
+          <a:ext cx="0" cy="0"/>
+          <a:chOff x="0" y="0"/>
+          <a:chExt cx="0" cy="0"/>
+        </a:xfrm>
+      </p:grpSpPr>
+      <p:sp>
+        <p:nvSpPr>
+          <p:cNvPr id="2" name="Slide Image Placeholder 1"/>
+          <p:cNvSpPr>
+            <a:spLocks noGrp="1" noRot="1" noChangeAspect="1"/>
+          </p:cNvSpPr>
+          <p:nvPr>
+            <p:ph type="sldImg"/>
+          </p:nvPr>
+        </p:nvSpPr>
+        <p:spPr/>
+      </p:sp>
+      <p:sp>
+        <p:nvSpPr>
+          <p:cNvPr id="3" name="Notes Placeholder 2"/>
+          <p:cNvSpPr>
+            <a:spLocks noGrp="1"/>
+          </p:cNvSpPr>
+          <p:nvPr>
+            <p:ph type="body" idx="1"/>
+          </p:nvPr>
+        </p:nvSpPr>
+        <p:spPr/>
+        <p:txBody>
+          <a:bodyPr/>
+          <a:lstStyle/>
+          <a:p>
+            <a:endParaRPr lang="zh-TW" altLang="en-US" dirty="0"/>
+          </a:p>
+        </p:txBody>
+      </p:sp>
+      <p:sp>
+        <p:nvSpPr>
+          <p:cNvPr id="4" name="Slide Number Placeholder 3"/>
+          <p:cNvSpPr>
+            <a:spLocks noGrp="1"/>
+          </p:cNvSpPr>
+          <p:nvPr>
+            <p:ph type="sldNum" sz="quarter" idx="5"/>
+          </p:nvPr>
+        </p:nvSpPr>
+        <p:spPr/>
+        <p:txBody>
+          <a:bodyPr/>
+          <a:lstStyle/>
+          <a:p>
+            <a:fld id="{7B37A861-61C3-4844-9E8F-4F4FC7449C66}" type="slidenum">
+              <a:rPr lang="zh-TW" altLang="en-US" smtClean="0"/>
+              <a:t>8</a:t>
+            </a:fld>
+            <a:endParaRPr lang="zh-TW" altLang="en-US"/>
+          </a:p>
+        </p:txBody>
+      </p:sp>
+    </p:spTree>
+    <p:extLst>
+      <p:ext uri="{BB962C8B-B14F-4D97-AF65-F5344CB8AC3E}">
+        <p14:creationId xmlns:p14="http://schemas.microsoft.com/office/powerpoint/2010/main" val="2056752409"/>
+      </p:ext>
+    </p:extLst>
+  </p:cSld>
+  <p:clrMapOvr>
+    <a:masterClrMapping/>
+  </p:clrMapOvr>
+</p:notes>
+</file>
+
+<file path=ppt/notesSlides/notesSlide9.xml><?xml version="1.0" encoding="utf-8"?>
+<p:notes xmlns:a="http://schemas.openxmlformats.org/drawingml/2006/main" xmlns:r="http://schemas.openxmlformats.org/officeDocument/2006/relationships" xmlns:p="http://schemas.openxmlformats.org/presentationml/2006/main">
+  <p:cSld>
+    <p:spTree>
+      <p:nvGrpSpPr>
+        <p:cNvPr id="1" name=""/>
+        <p:cNvGrpSpPr/>
+        <p:nvPr/>
+      </p:nvGrpSpPr>
+      <p:grpSpPr>
+        <a:xfrm>
+          <a:off x="0" y="0"/>
+          <a:ext cx="0" cy="0"/>
+          <a:chOff x="0" y="0"/>
+          <a:chExt cx="0" cy="0"/>
+        </a:xfrm>
+      </p:grpSpPr>
+      <p:sp>
+        <p:nvSpPr>
+          <p:cNvPr id="2" name="Slide Image Placeholder 1"/>
+          <p:cNvSpPr>
+            <a:spLocks noGrp="1" noRot="1" noChangeAspect="1"/>
+          </p:cNvSpPr>
+          <p:nvPr>
+            <p:ph type="sldImg"/>
+          </p:nvPr>
+        </p:nvSpPr>
+        <p:spPr/>
+      </p:sp>
+      <p:sp>
+        <p:nvSpPr>
+          <p:cNvPr id="3" name="Notes Placeholder 2"/>
+          <p:cNvSpPr>
+            <a:spLocks noGrp="1"/>
+          </p:cNvSpPr>
+          <p:nvPr>
+            <p:ph type="body" idx="1"/>
+          </p:nvPr>
+        </p:nvSpPr>
+        <p:spPr/>
+        <p:txBody>
+          <a:bodyPr/>
+          <a:lstStyle/>
+          <a:p>
+            <a:endParaRPr lang="zh-TW" altLang="en-US" dirty="0"/>
+          </a:p>
+        </p:txBody>
+      </p:sp>
+      <p:sp>
+        <p:nvSpPr>
+          <p:cNvPr id="4" name="Slide Number Placeholder 3"/>
+          <p:cNvSpPr>
+            <a:spLocks noGrp="1"/>
+          </p:cNvSpPr>
+          <p:nvPr>
+            <p:ph type="sldNum" sz="quarter" idx="5"/>
+          </p:nvPr>
+        </p:nvSpPr>
+        <p:spPr/>
+        <p:txBody>
+          <a:bodyPr/>
+          <a:lstStyle/>
+          <a:p>
+            <a:fld id="{7B37A861-61C3-4844-9E8F-4F4FC7449C66}" type="slidenum">
+              <a:rPr lang="zh-TW" altLang="en-US" smtClean="0"/>
+              <a:t>10</a:t>
+            </a:fld>
+            <a:endParaRPr lang="zh-TW" altLang="en-US"/>
+          </a:p>
+        </p:txBody>
+      </p:sp>
+    </p:spTree>
+    <p:extLst>
+      <p:ext uri="{BB962C8B-B14F-4D97-AF65-F5344CB8AC3E}">
+        <p14:creationId xmlns:p14="http://schemas.microsoft.com/office/powerpoint/2010/main" val="2698532399"/>
+      </p:ext>
+    </p:extLst>
+  </p:cSld>
+  <p:clrMapOvr>
+    <a:masterClrMapping/>
+  </p:clrMapOvr>
+</p:notes>
+</file>
+
 <file path=ppt/slideLayouts/slideLayout1.xml><?xml version="1.0" encoding="utf-8"?>
 <p:sldLayout xmlns:a="http://schemas.openxmlformats.org/drawingml/2006/main" xmlns:r="http://schemas.openxmlformats.org/officeDocument/2006/relationships" xmlns:p="http://schemas.openxmlformats.org/presentationml/2006/main" type="title" preserve="1">
   <p:cSld name="Title Slide">
@@ -438,7 +1547,7 @@
             <a:fld id="{1D8BD707-D9CF-40AE-B4C6-C98DA3205C09}" type="datetimeFigureOut">
               <a:rPr lang="en-US" smtClean="0"/>
               <a:pPr/>
-              <a:t>9/24/2026</a:t>
+              <a:t>10/1/2026</a:t>
             </a:fld>
             <a:endParaRPr lang="en-US"/>
           </a:p>
@@ -603,7 +1712,7 @@
             <a:fld id="{1D8BD707-D9CF-40AE-B4C6-C98DA3205C09}" type="datetimeFigureOut">
               <a:rPr lang="en-US" smtClean="0"/>
               <a:pPr/>
-              <a:t>9/24/2026</a:t>
+              <a:t>10/1/2026</a:t>
             </a:fld>
             <a:endParaRPr lang="en-US"/>
           </a:p>
@@ -778,7 +1887,7 @@
             <a:fld id="{1D8BD707-D9CF-40AE-B4C6-C98DA3205C09}" type="datetimeFigureOut">
               <a:rPr lang="en-US" smtClean="0"/>
               <a:pPr/>
-              <a:t>9/24/2026</a:t>
+              <a:t>10/1/2026</a:t>
             </a:fld>
             <a:endParaRPr lang="en-US"/>
           </a:p>
@@ -943,7 +2052,7 @@
             <a:fld id="{1D8BD707-D9CF-40AE-B4C6-C98DA3205C09}" type="datetimeFigureOut">
               <a:rPr lang="en-US" smtClean="0"/>
               <a:pPr/>
-              <a:t>9/24/2026</a:t>
+              <a:t>10/1/2026</a:t>
             </a:fld>
             <a:endParaRPr lang="en-US"/>
           </a:p>
@@ -1185,7 +2294,7 @@
             <a:fld id="{1D8BD707-D9CF-40AE-B4C6-C98DA3205C09}" type="datetimeFigureOut">
               <a:rPr lang="en-US" smtClean="0"/>
               <a:pPr/>
-              <a:t>9/24/2026</a:t>
+              <a:t>10/1/2026</a:t>
             </a:fld>
             <a:endParaRPr lang="en-US"/>
           </a:p>
@@ -1467,7 +2576,7 @@
             <a:fld id="{1D8BD707-D9CF-40AE-B4C6-C98DA3205C09}" type="datetimeFigureOut">
               <a:rPr lang="en-US" smtClean="0"/>
               <a:pPr/>
-              <a:t>9/24/2026</a:t>
+              <a:t>10/1/2026</a:t>
             </a:fld>
             <a:endParaRPr lang="en-US"/>
           </a:p>
@@ -1883,7 +2992,7 @@
             <a:fld id="{1D8BD707-D9CF-40AE-B4C6-C98DA3205C09}" type="datetimeFigureOut">
               <a:rPr lang="en-US" smtClean="0"/>
               <a:pPr/>
-              <a:t>9/24/2026</a:t>
+              <a:t>10/1/2026</a:t>
             </a:fld>
             <a:endParaRPr lang="en-US"/>
           </a:p>
@@ -1997,7 +3106,7 @@
             <a:fld id="{1D8BD707-D9CF-40AE-B4C6-C98DA3205C09}" type="datetimeFigureOut">
               <a:rPr lang="en-US" smtClean="0"/>
               <a:pPr/>
-              <a:t>9/24/2026</a:t>
+              <a:t>10/1/2026</a:t>
             </a:fld>
             <a:endParaRPr lang="en-US"/>
           </a:p>
@@ -2089,7 +3198,7 @@
             <a:fld id="{1D8BD707-D9CF-40AE-B4C6-C98DA3205C09}" type="datetimeFigureOut">
               <a:rPr lang="en-US" smtClean="0"/>
               <a:pPr/>
-              <a:t>9/24/2026</a:t>
+              <a:t>10/1/2026</a:t>
             </a:fld>
             <a:endParaRPr lang="en-US"/>
           </a:p>
@@ -2361,7 +3470,7 @@
             <a:fld id="{1D8BD707-D9CF-40AE-B4C6-C98DA3205C09}" type="datetimeFigureOut">
               <a:rPr lang="en-US" smtClean="0"/>
               <a:pPr/>
-              <a:t>9/24/2026</a:t>
+              <a:t>10/1/2026</a:t>
             </a:fld>
             <a:endParaRPr lang="en-US"/>
           </a:p>
@@ -2610,7 +3719,7 @@
             <a:fld id="{1D8BD707-D9CF-40AE-B4C6-C98DA3205C09}" type="datetimeFigureOut">
               <a:rPr lang="en-US" smtClean="0"/>
               <a:pPr/>
-              <a:t>9/24/2026</a:t>
+              <a:t>10/1/2026</a:t>
             </a:fld>
             <a:endParaRPr lang="en-US"/>
           </a:p>
@@ -2818,7 +3927,7 @@
             <a:fld id="{1D8BD707-D9CF-40AE-B4C6-C98DA3205C09}" type="datetimeFigureOut">
               <a:rPr lang="en-US" smtClean="0"/>
               <a:pPr/>
-              <a:t>9/24/2026</a:t>
+              <a:t>10/1/2026</a:t>
             </a:fld>
             <a:endParaRPr lang="en-US"/>
           </a:p>
@@ -7117,4 +8226,319 @@
   <a:objectDefaults/>
   <a:extraClrSchemeLst/>
 </a:theme>
+</file>
+
+<file path=ppt/theme/theme2.xml><?xml version="1.0" encoding="utf-8"?>
+<a:theme xmlns:a="http://schemas.openxmlformats.org/drawingml/2006/main" name="Office Theme">
+  <a:themeElements>
+    <a:clrScheme name="Office">
+      <a:dk1>
+        <a:sysClr val="windowText" lastClr="000000"/>
+      </a:dk1>
+      <a:lt1>
+        <a:sysClr val="window" lastClr="FFFFFF"/>
+      </a:lt1>
+      <a:dk2>
+        <a:srgbClr val="0E2841"/>
+      </a:dk2>
+      <a:lt2>
+        <a:srgbClr val="E8E8E8"/>
+      </a:lt2>
+      <a:accent1>
+        <a:srgbClr val="156082"/>
+      </a:accent1>
+      <a:accent2>
+        <a:srgbClr val="E97132"/>
+      </a:accent2>
+      <a:accent3>
+        <a:srgbClr val="196B24"/>
+      </a:accent3>
+      <a:accent4>
+        <a:srgbClr val="0F9ED5"/>
+      </a:accent4>
+      <a:accent5>
+        <a:srgbClr val="A02B93"/>
+      </a:accent5>
+      <a:accent6>
+        <a:srgbClr val="4EA72E"/>
+      </a:accent6>
+      <a:hlink>
+        <a:srgbClr val="467886"/>
+      </a:hlink>
+      <a:folHlink>
+        <a:srgbClr val="96607D"/>
+      </a:folHlink>
+    </a:clrScheme>
+    <a:fontScheme name="Office">
+      <a:majorFont>
+        <a:latin typeface="Aptos Display" panose="02110004020202020204"/>
+        <a:ea typeface=""/>
+        <a:cs typeface=""/>
+        <a:font script="Jpan" typeface="游ゴシック Light"/>
+        <a:font script="Hang" typeface="맑은 고딕"/>
+        <a:font script="Hans" typeface="等线 Light"/>
+        <a:font script="Hant" typeface="新細明體"/>
+        <a:font script="Arab" typeface="Times New Roman"/>
+        <a:font script="Hebr" typeface="Times New Roman"/>
+        <a:font script="Thai" typeface="Angsana New"/>
+        <a:font script="Ethi" typeface="Nyala"/>
+        <a:font script="Beng" typeface="Vrinda"/>
+        <a:font script="Gujr" typeface="Shruti"/>
+        <a:font script="Khmr" typeface="MoolBoran"/>
+        <a:font script="Knda" typeface="Tunga"/>
+        <a:font script="Guru" typeface="Raavi"/>
+        <a:font script="Cans" typeface="Euphemia"/>
+        <a:font script="Cher" typeface="Plantagenet Cherokee"/>
+        <a:font script="Yiii" typeface="Microsoft Yi Baiti"/>
+        <a:font script="Tibt" typeface="Microsoft Himalaya"/>
+        <a:font script="Thaa" typeface="MV Boli"/>
+        <a:font script="Deva" typeface="Mangal"/>
+        <a:font script="Telu" typeface="Gautami"/>
+        <a:font script="Taml" typeface="Latha"/>
+        <a:font script="Syrc" typeface="Estrangelo Edessa"/>
+        <a:font script="Orya" typeface="Kalinga"/>
+        <a:font script="Mlym" typeface="Kartika"/>
+        <a:font script="Laoo" typeface="DokChampa"/>
+        <a:font script="Sinh" typeface="Iskoola Pota"/>
+        <a:font script="Mong" typeface="Mongolian Baiti"/>
+        <a:font script="Viet" typeface="Times New Roman"/>
+        <a:font script="Uigh" typeface="Microsoft Uighur"/>
+        <a:font script="Geor" typeface="Sylfaen"/>
+        <a:font script="Armn" typeface="Arial"/>
+        <a:font script="Bugi" typeface="Leelawadee UI"/>
+        <a:font script="Bopo" typeface="Microsoft JhengHei"/>
+        <a:font script="Java" typeface="Javanese Text"/>
+        <a:font script="Lisu" typeface="Segoe UI"/>
+        <a:font script="Mymr" typeface="Myanmar Text"/>
+        <a:font script="Nkoo" typeface="Ebrima"/>
+        <a:font script="Olck" typeface="Nirmala UI"/>
+        <a:font script="Osma" typeface="Ebrima"/>
+        <a:font script="Phag" typeface="Phagspa"/>
+        <a:font script="Syrn" typeface="Estrangelo Edessa"/>
+        <a:font script="Syrj" typeface="Estrangelo Edessa"/>
+        <a:font script="Syre" typeface="Estrangelo Edessa"/>
+        <a:font script="Sora" typeface="Nirmala UI"/>
+        <a:font script="Tale" typeface="Microsoft Tai Le"/>
+        <a:font script="Talu" typeface="Microsoft New Tai Lue"/>
+        <a:font script="Tfng" typeface="Ebrima"/>
+      </a:majorFont>
+      <a:minorFont>
+        <a:latin typeface="Aptos" panose="02110004020202020204"/>
+        <a:ea typeface=""/>
+        <a:cs typeface=""/>
+        <a:font script="Jpan" typeface="游ゴシック"/>
+        <a:font script="Hang" typeface="맑은 고딕"/>
+        <a:font script="Hans" typeface="等线"/>
+        <a:font script="Hant" typeface="新細明體"/>
+        <a:font script="Arab" typeface="Arial"/>
+        <a:font script="Hebr" typeface="Arial"/>
+        <a:font script="Thai" typeface="Cordia New"/>
+        <a:font script="Ethi" typeface="Nyala"/>
+        <a:font script="Beng" typeface="Vrinda"/>
+        <a:font script="Gujr" typeface="Shruti"/>
+        <a:font script="Khmr" typeface="DaunPenh"/>
+        <a:font script="Knda" typeface="Tunga"/>
+        <a:font script="Guru" typeface="Raavi"/>
+        <a:font script="Cans" typeface="Euphemia"/>
+        <a:font script="Cher" typeface="Plantagenet Cherokee"/>
+        <a:font script="Yiii" typeface="Microsoft Yi Baiti"/>
+        <a:font script="Tibt" typeface="Microsoft Himalaya"/>
+        <a:font script="Thaa" typeface="MV Boli"/>
+        <a:font script="Deva" typeface="Mangal"/>
+        <a:font script="Telu" typeface="Gautami"/>
+        <a:font script="Taml" typeface="Latha"/>
+        <a:font script="Syrc" typeface="Estrangelo Edessa"/>
+        <a:font script="Orya" typeface="Kalinga"/>
+        <a:font script="Mlym" typeface="Kartika"/>
+        <a:font script="Laoo" typeface="DokChampa"/>
+        <a:font script="Sinh" typeface="Iskoola Pota"/>
+        <a:font script="Mong" typeface="Mongolian Baiti"/>
+        <a:font script="Viet" typeface="Arial"/>
+        <a:font script="Uigh" typeface="Microsoft Uighur"/>
+        <a:font script="Geor" typeface="Sylfaen"/>
+        <a:font script="Armn" typeface="Arial"/>
+        <a:font script="Bugi" typeface="Leelawadee UI"/>
+        <a:font script="Bopo" typeface="Microsoft JhengHei"/>
+        <a:font script="Java" typeface="Javanese Text"/>
+        <a:font script="Lisu" typeface="Segoe UI"/>
+        <a:font script="Mymr" typeface="Myanmar Text"/>
+        <a:font script="Nkoo" typeface="Ebrima"/>
+        <a:font script="Olck" typeface="Nirmala UI"/>
+        <a:font script="Osma" typeface="Ebrima"/>
+        <a:font script="Phag" typeface="Phagspa"/>
+        <a:font script="Syrn" typeface="Estrangelo Edessa"/>
+        <a:font script="Syrj" typeface="Estrangelo Edessa"/>
+        <a:font script="Syre" typeface="Estrangelo Edessa"/>
+        <a:font script="Sora" typeface="Nirmala UI"/>
+        <a:font script="Tale" typeface="Microsoft Tai Le"/>
+        <a:font script="Talu" typeface="Microsoft New Tai Lue"/>
+        <a:font script="Tfng" typeface="Ebrima"/>
+      </a:minorFont>
+    </a:fontScheme>
+    <a:fmtScheme name="Office">
+      <a:fillStyleLst>
+        <a:solidFill>
+          <a:schemeClr val="phClr"/>
+        </a:solidFill>
+        <a:gradFill rotWithShape="1">
+          <a:gsLst>
+            <a:gs pos="0">
+              <a:schemeClr val="phClr">
+                <a:lumMod val="110000"/>
+                <a:satMod val="105000"/>
+                <a:tint val="67000"/>
+              </a:schemeClr>
+            </a:gs>
+            <a:gs pos="50000">
+              <a:schemeClr val="phClr">
+                <a:lumMod val="105000"/>
+                <a:satMod val="103000"/>
+                <a:tint val="73000"/>
+              </a:schemeClr>
+            </a:gs>
+            <a:gs pos="100000">
+              <a:schemeClr val="phClr">
+                <a:lumMod val="105000"/>
+                <a:satMod val="109000"/>
+                <a:tint val="81000"/>
+              </a:schemeClr>
+            </a:gs>
+          </a:gsLst>
+          <a:lin ang="5400000" scaled="0"/>
+        </a:gradFill>
+        <a:gradFill rotWithShape="1">
+          <a:gsLst>
+            <a:gs pos="0">
+              <a:schemeClr val="phClr">
+                <a:satMod val="103000"/>
+                <a:lumMod val="102000"/>
+                <a:tint val="94000"/>
+              </a:schemeClr>
+            </a:gs>
+            <a:gs pos="50000">
+              <a:schemeClr val="phClr">
+                <a:satMod val="110000"/>
+                <a:lumMod val="100000"/>
+                <a:shade val="100000"/>
+              </a:schemeClr>
+            </a:gs>
+            <a:gs pos="100000">
+              <a:schemeClr val="phClr">
+                <a:lumMod val="99000"/>
+                <a:satMod val="120000"/>
+                <a:shade val="78000"/>
+              </a:schemeClr>
+            </a:gs>
+          </a:gsLst>
+          <a:lin ang="5400000" scaled="0"/>
+        </a:gradFill>
+      </a:fillStyleLst>
+      <a:lnStyleLst>
+        <a:ln w="12700" cap="flat" cmpd="sng" algn="ctr">
+          <a:solidFill>
+            <a:schemeClr val="phClr"/>
+          </a:solidFill>
+          <a:prstDash val="solid"/>
+          <a:miter lim="800000"/>
+        </a:ln>
+        <a:ln w="19050" cap="flat" cmpd="sng" algn="ctr">
+          <a:solidFill>
+            <a:schemeClr val="phClr"/>
+          </a:solidFill>
+          <a:prstDash val="solid"/>
+          <a:miter lim="800000"/>
+        </a:ln>
+        <a:ln w="25400" cap="flat" cmpd="sng" algn="ctr">
+          <a:solidFill>
+            <a:schemeClr val="phClr"/>
+          </a:solidFill>
+          <a:prstDash val="solid"/>
+          <a:miter lim="800000"/>
+        </a:ln>
+      </a:lnStyleLst>
+      <a:effectStyleLst>
+        <a:effectStyle>
+          <a:effectLst/>
+        </a:effectStyle>
+        <a:effectStyle>
+          <a:effectLst/>
+        </a:effectStyle>
+        <a:effectStyle>
+          <a:effectLst>
+            <a:outerShdw blurRad="57150" dist="19050" dir="5400000" algn="ctr" rotWithShape="0">
+              <a:srgbClr val="000000">
+                <a:alpha val="63000"/>
+              </a:srgbClr>
+            </a:outerShdw>
+          </a:effectLst>
+        </a:effectStyle>
+      </a:effectStyleLst>
+      <a:bgFillStyleLst>
+        <a:solidFill>
+          <a:schemeClr val="phClr"/>
+        </a:solidFill>
+        <a:solidFill>
+          <a:schemeClr val="phClr">
+            <a:tint val="95000"/>
+            <a:satMod val="170000"/>
+          </a:schemeClr>
+        </a:solidFill>
+        <a:gradFill rotWithShape="1">
+          <a:gsLst>
+            <a:gs pos="0">
+              <a:schemeClr val="phClr">
+                <a:tint val="93000"/>
+                <a:satMod val="150000"/>
+                <a:shade val="98000"/>
+                <a:lumMod val="102000"/>
+              </a:schemeClr>
+            </a:gs>
+            <a:gs pos="50000">
+              <a:schemeClr val="phClr">
+                <a:tint val="98000"/>
+                <a:satMod val="130000"/>
+                <a:shade val="90000"/>
+                <a:lumMod val="103000"/>
+              </a:schemeClr>
+            </a:gs>
+            <a:gs pos="100000">
+              <a:schemeClr val="phClr">
+                <a:shade val="63000"/>
+                <a:satMod val="120000"/>
+              </a:schemeClr>
+            </a:gs>
+          </a:gsLst>
+          <a:lin ang="5400000" scaled="0"/>
+        </a:gradFill>
+      </a:bgFillStyleLst>
+    </a:fmtScheme>
+  </a:themeElements>
+  <a:objectDefaults>
+    <a:lnDef>
+      <a:spPr/>
+      <a:bodyPr/>
+      <a:lstStyle/>
+      <a:style>
+        <a:lnRef idx="2">
+          <a:schemeClr val="accent1"/>
+        </a:lnRef>
+        <a:fillRef idx="0">
+          <a:schemeClr val="accent1"/>
+        </a:fillRef>
+        <a:effectRef idx="1">
+          <a:schemeClr val="accent1"/>
+        </a:effectRef>
+        <a:fontRef idx="minor">
+          <a:schemeClr val="tx1"/>
+        </a:fontRef>
+      </a:style>
+    </a:lnDef>
+  </a:objectDefaults>
+  <a:extraClrSchemeLst/>
+  <a:extLst>
+    <a:ext uri="{05A4C25C-085E-4340-85A3-A5531E510DB2}">
+      <thm15:themeFamily xmlns:thm15="http://schemas.microsoft.com/office/thememl/2012/main" name="Office Theme" id="{2E142A2C-CD16-42D6-873A-C26D2A0506FA}" vid="{1BDDFF52-6CD6-40A5-AB3C-68EB2F1E4D0A}"/>
+    </a:ext>
+  </a:extLst>
+</a:theme>
 </file>
</xml_diff>